<commit_message>
docs(cloud): split into cheap trial tier vs strong paid tier
Trial/free path strips GKE/NAT/Cloud SQL (fixed ~$22/mo, ~$0 per team idle)
while keeping the gVisor kernel sandbox via Cloud Run scale-to-zero. Paid/pro
keeps GKE Sandbox 24/7. Updates plan doc + deck (tier table, cost slides,
scenarios) and documents the weaker shared-engine option as a non-chosen
lever.

Co-Authored-By: Claude Opus 4.8 <noreply@anthropic.com>
Claude-Session: https://claude.ai/code/session_01M1BqSKcPNCM3wQtvWHn37c
</commit_message>
<xml_diff>
--- a/cloud/houston-cloud-gcp.pptx
+++ b/cloud/houston-cloud-gcp.pptx
@@ -3696,8 +3696,8 @@
         </p:nvSpPr>
         <p:spPr>
           <a:xfrm>
-            <a:off x="731520" y="1920240"/>
-            <a:ext cx="2858548" cy="420624"/>
+            <a:off x="731520" y="1874519"/>
+            <a:ext cx="3083983" cy="420624"/>
           </a:xfrm>
           <a:prstGeom prst="rect">
             <a:avLst/>
@@ -3740,8 +3740,8 @@
         </p:nvSpPr>
         <p:spPr>
           <a:xfrm>
-            <a:off x="804672" y="1920240"/>
-            <a:ext cx="2712244" cy="420624"/>
+            <a:off x="804672" y="1874519"/>
+            <a:ext cx="2937679" cy="420624"/>
           </a:xfrm>
           <a:prstGeom prst="rect">
             <a:avLst/>
@@ -3779,8 +3779,8 @@
         </p:nvSpPr>
         <p:spPr>
           <a:xfrm>
-            <a:off x="3590068" y="1920240"/>
-            <a:ext cx="1281418" cy="420624"/>
+            <a:off x="3815503" y="1874519"/>
+            <a:ext cx="1193800" cy="420624"/>
           </a:xfrm>
           <a:prstGeom prst="rect">
             <a:avLst/>
@@ -3823,8 +3823,8 @@
         </p:nvSpPr>
         <p:spPr>
           <a:xfrm>
-            <a:off x="3663220" y="1920240"/>
-            <a:ext cx="1135114" cy="420624"/>
+            <a:off x="3888655" y="1874519"/>
+            <a:ext cx="1047496" cy="420624"/>
           </a:xfrm>
           <a:prstGeom prst="rect">
             <a:avLst/>
@@ -3862,8 +3862,8 @@
         </p:nvSpPr>
         <p:spPr>
           <a:xfrm>
-            <a:off x="4871486" y="1920240"/>
-            <a:ext cx="2661407" cy="420624"/>
+            <a:off x="5009303" y="1874519"/>
+            <a:ext cx="2586566" cy="420624"/>
           </a:xfrm>
           <a:prstGeom prst="rect">
             <a:avLst/>
@@ -3906,8 +3906,8 @@
         </p:nvSpPr>
         <p:spPr>
           <a:xfrm>
-            <a:off x="4944638" y="1920240"/>
-            <a:ext cx="2515103" cy="420624"/>
+            <a:off x="5082455" y="1874519"/>
+            <a:ext cx="2440262" cy="420624"/>
           </a:xfrm>
           <a:prstGeom prst="rect">
             <a:avLst/>
@@ -3945,8 +3945,8 @@
         </p:nvSpPr>
         <p:spPr>
           <a:xfrm>
-            <a:off x="7532894" y="1920240"/>
-            <a:ext cx="2365695" cy="420624"/>
+            <a:off x="7595869" y="1874519"/>
+            <a:ext cx="2387600" cy="420624"/>
           </a:xfrm>
           <a:prstGeom prst="rect">
             <a:avLst/>
@@ -3989,8 +3989,8 @@
         </p:nvSpPr>
         <p:spPr>
           <a:xfrm>
-            <a:off x="7606046" y="1920240"/>
-            <a:ext cx="2219391" cy="420624"/>
+            <a:off x="7669021" y="1874519"/>
+            <a:ext cx="2241296" cy="420624"/>
           </a:xfrm>
           <a:prstGeom prst="rect">
             <a:avLst/>
@@ -4028,8 +4028,8 @@
         </p:nvSpPr>
         <p:spPr>
           <a:xfrm>
-            <a:off x="9898589" y="1920240"/>
-            <a:ext cx="1577130" cy="420624"/>
+            <a:off x="9983469" y="1874519"/>
+            <a:ext cx="1492249" cy="420624"/>
           </a:xfrm>
           <a:prstGeom prst="rect">
             <a:avLst/>
@@ -4072,8 +4072,8 @@
         </p:nvSpPr>
         <p:spPr>
           <a:xfrm>
-            <a:off x="9971741" y="1920240"/>
-            <a:ext cx="1430826" cy="420624"/>
+            <a:off x="10056621" y="1874519"/>
+            <a:ext cx="1345945" cy="420624"/>
           </a:xfrm>
           <a:prstGeom prst="rect">
             <a:avLst/>
@@ -4111,8 +4111,8 @@
         </p:nvSpPr>
         <p:spPr>
           <a:xfrm>
-            <a:off x="731520" y="2340864"/>
-            <a:ext cx="2858548" cy="475488"/>
+            <a:off x="731520" y="2295144"/>
+            <a:ext cx="3083983" cy="457200"/>
           </a:xfrm>
           <a:prstGeom prst="rect">
             <a:avLst/>
@@ -4155,8 +4155,8 @@
         </p:nvSpPr>
         <p:spPr>
           <a:xfrm>
-            <a:off x="804672" y="2340864"/>
-            <a:ext cx="2712244" cy="475488"/>
+            <a:off x="804672" y="2295144"/>
+            <a:ext cx="2937679" cy="457200"/>
           </a:xfrm>
           <a:prstGeom prst="rect">
             <a:avLst/>
@@ -4181,7 +4181,7 @@
                 </a:solidFill>
                 <a:latin typeface="Arial"/>
               </a:rPr>
-              <a:t>50 equipos Pro</a:t>
+              <a:t>Solo prueba: 2,000 free (BYO)</a:t>
             </a:r>
           </a:p>
         </p:txBody>
@@ -4194,8 +4194,8 @@
         </p:nvSpPr>
         <p:spPr>
           <a:xfrm>
-            <a:off x="3590068" y="2340864"/>
-            <a:ext cx="1281418" cy="475488"/>
+            <a:off x="3815503" y="2295144"/>
+            <a:ext cx="1193800" cy="457200"/>
           </a:xfrm>
           <a:prstGeom prst="rect">
             <a:avLst/>
@@ -4238,8 +4238,8 @@
         </p:nvSpPr>
         <p:spPr>
           <a:xfrm>
-            <a:off x="3663220" y="2340864"/>
-            <a:ext cx="1135114" cy="475488"/>
+            <a:off x="3888655" y="2295144"/>
+            <a:ext cx="1047496" cy="457200"/>
           </a:xfrm>
           <a:prstGeom prst="rect">
             <a:avLst/>
@@ -4264,7 +4264,7 @@
                 </a:solidFill>
                 <a:latin typeface="Arial"/>
               </a:rPr>
-              <a:t>$186</a:t>
+              <a:t>$22</a:t>
             </a:r>
           </a:p>
         </p:txBody>
@@ -4277,8 +4277,8 @@
         </p:nvSpPr>
         <p:spPr>
           <a:xfrm>
-            <a:off x="4871486" y="2340864"/>
-            <a:ext cx="2661407" cy="475488"/>
+            <a:off x="5009303" y="2295144"/>
+            <a:ext cx="2586566" cy="457200"/>
           </a:xfrm>
           <a:prstGeom prst="rect">
             <a:avLst/>
@@ -4321,8 +4321,8 @@
         </p:nvSpPr>
         <p:spPr>
           <a:xfrm>
-            <a:off x="4944638" y="2340864"/>
-            <a:ext cx="2515103" cy="475488"/>
+            <a:off x="5082455" y="2295144"/>
+            <a:ext cx="2440262" cy="457200"/>
           </a:xfrm>
           <a:prstGeom prst="rect">
             <a:avLst/>
@@ -4347,7 +4347,7 @@
                 </a:solidFill>
                 <a:latin typeface="Arial"/>
               </a:rPr>
-              <a:t>50 × $7 = $350</a:t>
+              <a:t>~$0 idle</a:t>
             </a:r>
           </a:p>
         </p:txBody>
@@ -4360,8 +4360,8 @@
         </p:nvSpPr>
         <p:spPr>
           <a:xfrm>
-            <a:off x="7532894" y="2340864"/>
-            <a:ext cx="2365695" cy="475488"/>
+            <a:off x="7595869" y="2295144"/>
+            <a:ext cx="2387600" cy="457200"/>
           </a:xfrm>
           <a:prstGeom prst="rect">
             <a:avLst/>
@@ -4404,8 +4404,8 @@
         </p:nvSpPr>
         <p:spPr>
           <a:xfrm>
-            <a:off x="7606046" y="2340864"/>
-            <a:ext cx="2219391" cy="475488"/>
+            <a:off x="7669021" y="2295144"/>
+            <a:ext cx="2241296" cy="457200"/>
           </a:xfrm>
           <a:prstGeom prst="rect">
             <a:avLst/>
@@ -4430,7 +4430,7 @@
                 </a:solidFill>
                 <a:latin typeface="Arial"/>
               </a:rPr>
-              <a:t>≈ $536</a:t>
+              <a:t>≈ $22–100</a:t>
             </a:r>
           </a:p>
         </p:txBody>
@@ -4443,8 +4443,8 @@
         </p:nvSpPr>
         <p:spPr>
           <a:xfrm>
-            <a:off x="9898589" y="2340864"/>
-            <a:ext cx="1577130" cy="475488"/>
+            <a:off x="9983469" y="2295144"/>
+            <a:ext cx="1492249" cy="457200"/>
           </a:xfrm>
           <a:prstGeom prst="rect">
             <a:avLst/>
@@ -4487,8 +4487,8 @@
         </p:nvSpPr>
         <p:spPr>
           <a:xfrm>
-            <a:off x="9971741" y="2340864"/>
-            <a:ext cx="1430826" cy="475488"/>
+            <a:off x="10056621" y="2295144"/>
+            <a:ext cx="1345945" cy="457200"/>
           </a:xfrm>
           <a:prstGeom prst="rect">
             <a:avLst/>
@@ -4513,7 +4513,7 @@
                 </a:solidFill>
                 <a:latin typeface="Arial"/>
               </a:rPr>
-              <a:t>≈ $10.7</a:t>
+              <a:t>≈ $0.02</a:t>
             </a:r>
           </a:p>
         </p:txBody>
@@ -4526,8 +4526,8 @@
         </p:nvSpPr>
         <p:spPr>
           <a:xfrm>
-            <a:off x="731520" y="2816352"/>
-            <a:ext cx="2858548" cy="475488"/>
+            <a:off x="731520" y="2752344"/>
+            <a:ext cx="3083983" cy="457200"/>
           </a:xfrm>
           <a:prstGeom prst="rect">
             <a:avLst/>
@@ -4570,8 +4570,8 @@
         </p:nvSpPr>
         <p:spPr>
           <a:xfrm>
-            <a:off x="804672" y="2816352"/>
-            <a:ext cx="2712244" cy="475488"/>
+            <a:off x="804672" y="2752344"/>
+            <a:ext cx="2937679" cy="457200"/>
           </a:xfrm>
           <a:prstGeom prst="rect">
             <a:avLst/>
@@ -4596,7 +4596,7 @@
                 </a:solidFill>
                 <a:latin typeface="Arial"/>
               </a:rPr>
-              <a:t>200 equipos Pro</a:t>
+              <a:t>50 equipos Pago</a:t>
             </a:r>
           </a:p>
         </p:txBody>
@@ -4609,8 +4609,8 @@
         </p:nvSpPr>
         <p:spPr>
           <a:xfrm>
-            <a:off x="3590068" y="2816352"/>
-            <a:ext cx="1281418" cy="475488"/>
+            <a:off x="3815503" y="2752344"/>
+            <a:ext cx="1193800" cy="457200"/>
           </a:xfrm>
           <a:prstGeom prst="rect">
             <a:avLst/>
@@ -4653,8 +4653,8 @@
         </p:nvSpPr>
         <p:spPr>
           <a:xfrm>
-            <a:off x="3663220" y="2816352"/>
-            <a:ext cx="1135114" cy="475488"/>
+            <a:off x="3888655" y="2752344"/>
+            <a:ext cx="1047496" cy="457200"/>
           </a:xfrm>
           <a:prstGeom prst="rect">
             <a:avLst/>
@@ -4692,8 +4692,8 @@
         </p:nvSpPr>
         <p:spPr>
           <a:xfrm>
-            <a:off x="4871486" y="2816352"/>
-            <a:ext cx="2661407" cy="475488"/>
+            <a:off x="5009303" y="2752344"/>
+            <a:ext cx="2586566" cy="457200"/>
           </a:xfrm>
           <a:prstGeom prst="rect">
             <a:avLst/>
@@ -4736,8 +4736,8 @@
         </p:nvSpPr>
         <p:spPr>
           <a:xfrm>
-            <a:off x="4944638" y="2816352"/>
-            <a:ext cx="2515103" cy="475488"/>
+            <a:off x="5082455" y="2752344"/>
+            <a:ext cx="2440262" cy="457200"/>
           </a:xfrm>
           <a:prstGeom prst="rect">
             <a:avLst/>
@@ -4762,7 +4762,7 @@
                 </a:solidFill>
                 <a:latin typeface="Arial"/>
               </a:rPr>
-              <a:t>200 × $6 = $1,200</a:t>
+              <a:t>50 × $7 = $350</a:t>
             </a:r>
           </a:p>
         </p:txBody>
@@ -4775,8 +4775,8 @@
         </p:nvSpPr>
         <p:spPr>
           <a:xfrm>
-            <a:off x="7532894" y="2816352"/>
-            <a:ext cx="2365695" cy="475488"/>
+            <a:off x="7595869" y="2752344"/>
+            <a:ext cx="2387600" cy="457200"/>
           </a:xfrm>
           <a:prstGeom prst="rect">
             <a:avLst/>
@@ -4819,8 +4819,8 @@
         </p:nvSpPr>
         <p:spPr>
           <a:xfrm>
-            <a:off x="7606046" y="2816352"/>
-            <a:ext cx="2219391" cy="475488"/>
+            <a:off x="7669021" y="2752344"/>
+            <a:ext cx="2241296" cy="457200"/>
           </a:xfrm>
           <a:prstGeom prst="rect">
             <a:avLst/>
@@ -4845,7 +4845,7 @@
                 </a:solidFill>
                 <a:latin typeface="Arial"/>
               </a:rPr>
-              <a:t>≈ $1,386</a:t>
+              <a:t>≈ $536</a:t>
             </a:r>
           </a:p>
         </p:txBody>
@@ -4858,8 +4858,8 @@
         </p:nvSpPr>
         <p:spPr>
           <a:xfrm>
-            <a:off x="9898589" y="2816352"/>
-            <a:ext cx="1577130" cy="475488"/>
+            <a:off x="9983469" y="2752344"/>
+            <a:ext cx="1492249" cy="457200"/>
           </a:xfrm>
           <a:prstGeom prst="rect">
             <a:avLst/>
@@ -4902,8 +4902,8 @@
         </p:nvSpPr>
         <p:spPr>
           <a:xfrm>
-            <a:off x="9971741" y="2816352"/>
-            <a:ext cx="1430826" cy="475488"/>
+            <a:off x="10056621" y="2752344"/>
+            <a:ext cx="1345945" cy="457200"/>
           </a:xfrm>
           <a:prstGeom prst="rect">
             <a:avLst/>
@@ -4928,7 +4928,7 @@
                 </a:solidFill>
                 <a:latin typeface="Arial"/>
               </a:rPr>
-              <a:t>≈ $6.9</a:t>
+              <a:t>≈ $10.7</a:t>
             </a:r>
           </a:p>
         </p:txBody>
@@ -4941,8 +4941,8 @@
         </p:nvSpPr>
         <p:spPr>
           <a:xfrm>
-            <a:off x="731520" y="3291840"/>
-            <a:ext cx="2858548" cy="475488"/>
+            <a:off x="731520" y="3209544"/>
+            <a:ext cx="3083983" cy="457200"/>
           </a:xfrm>
           <a:prstGeom prst="rect">
             <a:avLst/>
@@ -4985,8 +4985,8 @@
         </p:nvSpPr>
         <p:spPr>
           <a:xfrm>
-            <a:off x="804672" y="3291840"/>
-            <a:ext cx="2712244" cy="475488"/>
+            <a:off x="804672" y="3209544"/>
+            <a:ext cx="2937679" cy="457200"/>
           </a:xfrm>
           <a:prstGeom prst="rect">
             <a:avLst/>
@@ -5011,7 +5011,7 @@
                 </a:solidFill>
                 <a:latin typeface="Arial"/>
               </a:rPr>
-              <a:t>100 Pro + 400 Free</a:t>
+              <a:t>200 equipos Pago</a:t>
             </a:r>
           </a:p>
         </p:txBody>
@@ -5024,8 +5024,8 @@
         </p:nvSpPr>
         <p:spPr>
           <a:xfrm>
-            <a:off x="3590068" y="3291840"/>
-            <a:ext cx="1281418" cy="475488"/>
+            <a:off x="3815503" y="3209544"/>
+            <a:ext cx="1193800" cy="457200"/>
           </a:xfrm>
           <a:prstGeom prst="rect">
             <a:avLst/>
@@ -5068,8 +5068,8 @@
         </p:nvSpPr>
         <p:spPr>
           <a:xfrm>
-            <a:off x="3663220" y="3291840"/>
-            <a:ext cx="1135114" cy="475488"/>
+            <a:off x="3888655" y="3209544"/>
+            <a:ext cx="1047496" cy="457200"/>
           </a:xfrm>
           <a:prstGeom prst="rect">
             <a:avLst/>
@@ -5107,8 +5107,8 @@
         </p:nvSpPr>
         <p:spPr>
           <a:xfrm>
-            <a:off x="4871486" y="3291840"/>
-            <a:ext cx="2661407" cy="475488"/>
+            <a:off x="5009303" y="3209544"/>
+            <a:ext cx="2586566" cy="457200"/>
           </a:xfrm>
           <a:prstGeom prst="rect">
             <a:avLst/>
@@ -5151,8 +5151,8 @@
         </p:nvSpPr>
         <p:spPr>
           <a:xfrm>
-            <a:off x="4944638" y="3291840"/>
-            <a:ext cx="2515103" cy="475488"/>
+            <a:off x="5082455" y="3209544"/>
+            <a:ext cx="2440262" cy="457200"/>
           </a:xfrm>
           <a:prstGeom prst="rect">
             <a:avLst/>
@@ -5177,7 +5177,7 @@
                 </a:solidFill>
                 <a:latin typeface="Arial"/>
               </a:rPr>
-              <a:t>$700 + $400</a:t>
+              <a:t>200 × $6 = $1,200</a:t>
             </a:r>
           </a:p>
         </p:txBody>
@@ -5190,8 +5190,8 @@
         </p:nvSpPr>
         <p:spPr>
           <a:xfrm>
-            <a:off x="7532894" y="3291840"/>
-            <a:ext cx="2365695" cy="475488"/>
+            <a:off x="7595869" y="3209544"/>
+            <a:ext cx="2387600" cy="457200"/>
           </a:xfrm>
           <a:prstGeom prst="rect">
             <a:avLst/>
@@ -5234,8 +5234,8 @@
         </p:nvSpPr>
         <p:spPr>
           <a:xfrm>
-            <a:off x="7606046" y="3291840"/>
-            <a:ext cx="2219391" cy="475488"/>
+            <a:off x="7669021" y="3209544"/>
+            <a:ext cx="2241296" cy="457200"/>
           </a:xfrm>
           <a:prstGeom prst="rect">
             <a:avLst/>
@@ -5260,7 +5260,7 @@
                 </a:solidFill>
                 <a:latin typeface="Arial"/>
               </a:rPr>
-              <a:t>≈ $1,286</a:t>
+              <a:t>≈ $1,386</a:t>
             </a:r>
           </a:p>
         </p:txBody>
@@ -5273,8 +5273,8 @@
         </p:nvSpPr>
         <p:spPr>
           <a:xfrm>
-            <a:off x="9898589" y="3291840"/>
-            <a:ext cx="1577130" cy="475488"/>
+            <a:off x="9983469" y="3209544"/>
+            <a:ext cx="1492249" cy="457200"/>
           </a:xfrm>
           <a:prstGeom prst="rect">
             <a:avLst/>
@@ -5317,8 +5317,8 @@
         </p:nvSpPr>
         <p:spPr>
           <a:xfrm>
-            <a:off x="9971741" y="3291840"/>
-            <a:ext cx="1430826" cy="475488"/>
+            <a:off x="10056621" y="3209544"/>
+            <a:ext cx="1345945" cy="457200"/>
           </a:xfrm>
           <a:prstGeom prst="rect">
             <a:avLst/>
@@ -5343,7 +5343,7 @@
                 </a:solidFill>
                 <a:latin typeface="Arial"/>
               </a:rPr>
-              <a:t>≈ $2.6</a:t>
+              <a:t>≈ $6.9</a:t>
             </a:r>
           </a:p>
         </p:txBody>
@@ -5356,8 +5356,8 @@
         </p:nvSpPr>
         <p:spPr>
           <a:xfrm>
-            <a:off x="731520" y="3767328"/>
-            <a:ext cx="2858548" cy="475488"/>
+            <a:off x="731520" y="3666744"/>
+            <a:ext cx="3083983" cy="457200"/>
           </a:xfrm>
           <a:prstGeom prst="rect">
             <a:avLst/>
@@ -5400,8 +5400,8 @@
         </p:nvSpPr>
         <p:spPr>
           <a:xfrm>
-            <a:off x="804672" y="3767328"/>
-            <a:ext cx="2712244" cy="475488"/>
+            <a:off x="804672" y="3666744"/>
+            <a:ext cx="2937679" cy="457200"/>
           </a:xfrm>
           <a:prstGeom prst="rect">
             <a:avLst/>
@@ -5426,7 +5426,7 @@
                 </a:solidFill>
                 <a:latin typeface="Arial"/>
               </a:rPr>
-              <a:t>500 equipos Pro</a:t>
+              <a:t>100 Pago + 400 prueba</a:t>
             </a:r>
           </a:p>
         </p:txBody>
@@ -5439,8 +5439,8 @@
         </p:nvSpPr>
         <p:spPr>
           <a:xfrm>
-            <a:off x="3590068" y="3767328"/>
-            <a:ext cx="1281418" cy="475488"/>
+            <a:off x="3815503" y="3666744"/>
+            <a:ext cx="1193800" cy="457200"/>
           </a:xfrm>
           <a:prstGeom prst="rect">
             <a:avLst/>
@@ -5483,8 +5483,8 @@
         </p:nvSpPr>
         <p:spPr>
           <a:xfrm>
-            <a:off x="3663220" y="3767328"/>
-            <a:ext cx="1135114" cy="475488"/>
+            <a:off x="3888655" y="3666744"/>
+            <a:ext cx="1047496" cy="457200"/>
           </a:xfrm>
           <a:prstGeom prst="rect">
             <a:avLst/>
@@ -5522,8 +5522,8 @@
         </p:nvSpPr>
         <p:spPr>
           <a:xfrm>
-            <a:off x="4871486" y="3767328"/>
-            <a:ext cx="2661407" cy="475488"/>
+            <a:off x="5009303" y="3666744"/>
+            <a:ext cx="2586566" cy="457200"/>
           </a:xfrm>
           <a:prstGeom prst="rect">
             <a:avLst/>
@@ -5566,8 +5566,8 @@
         </p:nvSpPr>
         <p:spPr>
           <a:xfrm>
-            <a:off x="4944638" y="3767328"/>
-            <a:ext cx="2515103" cy="475488"/>
+            <a:off x="5082455" y="3666744"/>
+            <a:ext cx="2440262" cy="457200"/>
           </a:xfrm>
           <a:prstGeom prst="rect">
             <a:avLst/>
@@ -5592,7 +5592,7 @@
                 </a:solidFill>
                 <a:latin typeface="Arial"/>
               </a:rPr>
-              <a:t>500 × $5.5 = $2,750</a:t>
+              <a:t>$700 + ~$0</a:t>
             </a:r>
           </a:p>
         </p:txBody>
@@ -5605,8 +5605,8 @@
         </p:nvSpPr>
         <p:spPr>
           <a:xfrm>
-            <a:off x="7532894" y="3767328"/>
-            <a:ext cx="2365695" cy="475488"/>
+            <a:off x="7595869" y="3666744"/>
+            <a:ext cx="2387600" cy="457200"/>
           </a:xfrm>
           <a:prstGeom prst="rect">
             <a:avLst/>
@@ -5649,8 +5649,8 @@
         </p:nvSpPr>
         <p:spPr>
           <a:xfrm>
-            <a:off x="7606046" y="3767328"/>
-            <a:ext cx="2219391" cy="475488"/>
+            <a:off x="7669021" y="3666744"/>
+            <a:ext cx="2241296" cy="457200"/>
           </a:xfrm>
           <a:prstGeom prst="rect">
             <a:avLst/>
@@ -5675,7 +5675,7 @@
                 </a:solidFill>
                 <a:latin typeface="Arial"/>
               </a:rPr>
-              <a:t>≈ $2,936</a:t>
+              <a:t>≈ $886</a:t>
             </a:r>
           </a:p>
         </p:txBody>
@@ -5688,8 +5688,8 @@
         </p:nvSpPr>
         <p:spPr>
           <a:xfrm>
-            <a:off x="9898589" y="3767328"/>
-            <a:ext cx="1577130" cy="475488"/>
+            <a:off x="9983469" y="3666744"/>
+            <a:ext cx="1492249" cy="457200"/>
           </a:xfrm>
           <a:prstGeom prst="rect">
             <a:avLst/>
@@ -5732,8 +5732,8 @@
         </p:nvSpPr>
         <p:spPr>
           <a:xfrm>
-            <a:off x="9971741" y="3767328"/>
-            <a:ext cx="1430826" cy="475488"/>
+            <a:off x="10056621" y="3666744"/>
+            <a:ext cx="1345945" cy="457200"/>
           </a:xfrm>
           <a:prstGeom prst="rect">
             <a:avLst/>
@@ -5758,6 +5758,421 @@
                 </a:solidFill>
                 <a:latin typeface="Arial"/>
               </a:rPr>
+              <a:t>≈ $1.8</a:t>
+            </a:r>
+          </a:p>
+        </p:txBody>
+      </p:sp>
+      <p:sp>
+        <p:nvSpPr>
+          <p:cNvPr id="57" name="Rectangle 56"/>
+          <p:cNvSpPr/>
+          <p:nvPr/>
+        </p:nvSpPr>
+        <p:spPr>
+          <a:xfrm>
+            <a:off x="731520" y="4123944"/>
+            <a:ext cx="3083983" cy="457200"/>
+          </a:xfrm>
+          <a:prstGeom prst="rect">
+            <a:avLst/>
+          </a:prstGeom>
+          <a:solidFill>
+            <a:srgbClr val="151D38"/>
+          </a:solidFill>
+          <a:ln>
+            <a:noFill/>
+          </a:ln>
+          <a:effectLst/>
+        </p:spPr>
+        <p:style>
+          <a:lnRef idx="1">
+            <a:schemeClr val="accent1"/>
+          </a:lnRef>
+          <a:fillRef idx="3">
+            <a:schemeClr val="accent1"/>
+          </a:fillRef>
+          <a:effectRef idx="2">
+            <a:schemeClr val="accent1"/>
+          </a:effectRef>
+          <a:fontRef idx="minor">
+            <a:schemeClr val="lt1"/>
+          </a:fontRef>
+        </p:style>
+        <p:txBody>
+          <a:bodyPr rtlCol="0" anchor="ctr"/>
+          <a:lstStyle/>
+          <a:p>
+            <a:pPr algn="ctr"/>
+          </a:p>
+        </p:txBody>
+      </p:sp>
+      <p:sp>
+        <p:nvSpPr>
+          <p:cNvPr id="58" name="TextBox 57"/>
+          <p:cNvSpPr txBox="1"/>
+          <p:nvPr/>
+        </p:nvSpPr>
+        <p:spPr>
+          <a:xfrm>
+            <a:off x="804672" y="4123944"/>
+            <a:ext cx="2937679" cy="457200"/>
+          </a:xfrm>
+          <a:prstGeom prst="rect">
+            <a:avLst/>
+          </a:prstGeom>
+          <a:noFill/>
+        </p:spPr>
+        <p:txBody>
+          <a:bodyPr wrap="square" anchor="ctr">
+            <a:spAutoFit/>
+          </a:bodyPr>
+          <a:lstStyle/>
+          <a:p>
+            <a:pPr algn="l">
+              <a:spcAft>
+                <a:spcPts val="400"/>
+              </a:spcAft>
+            </a:pPr>
+            <a:r>
+              <a:rPr sz="1150" b="1">
+                <a:solidFill>
+                  <a:srgbClr val="EDF1FF"/>
+                </a:solidFill>
+                <a:latin typeface="Arial"/>
+              </a:rPr>
+              <a:t>500 equipos Pago</a:t>
+            </a:r>
+          </a:p>
+        </p:txBody>
+      </p:sp>
+      <p:sp>
+        <p:nvSpPr>
+          <p:cNvPr id="59" name="Rectangle 58"/>
+          <p:cNvSpPr/>
+          <p:nvPr/>
+        </p:nvSpPr>
+        <p:spPr>
+          <a:xfrm>
+            <a:off x="3815503" y="4123944"/>
+            <a:ext cx="1193800" cy="457200"/>
+          </a:xfrm>
+          <a:prstGeom prst="rect">
+            <a:avLst/>
+          </a:prstGeom>
+          <a:solidFill>
+            <a:srgbClr val="151D38"/>
+          </a:solidFill>
+          <a:ln>
+            <a:noFill/>
+          </a:ln>
+          <a:effectLst/>
+        </p:spPr>
+        <p:style>
+          <a:lnRef idx="1">
+            <a:schemeClr val="accent1"/>
+          </a:lnRef>
+          <a:fillRef idx="3">
+            <a:schemeClr val="accent1"/>
+          </a:fillRef>
+          <a:effectRef idx="2">
+            <a:schemeClr val="accent1"/>
+          </a:effectRef>
+          <a:fontRef idx="minor">
+            <a:schemeClr val="lt1"/>
+          </a:fontRef>
+        </p:style>
+        <p:txBody>
+          <a:bodyPr rtlCol="0" anchor="ctr"/>
+          <a:lstStyle/>
+          <a:p>
+            <a:pPr algn="ctr"/>
+          </a:p>
+        </p:txBody>
+      </p:sp>
+      <p:sp>
+        <p:nvSpPr>
+          <p:cNvPr id="60" name="TextBox 59"/>
+          <p:cNvSpPr txBox="1"/>
+          <p:nvPr/>
+        </p:nvSpPr>
+        <p:spPr>
+          <a:xfrm>
+            <a:off x="3888655" y="4123944"/>
+            <a:ext cx="1047496" cy="457200"/>
+          </a:xfrm>
+          <a:prstGeom prst="rect">
+            <a:avLst/>
+          </a:prstGeom>
+          <a:noFill/>
+        </p:spPr>
+        <p:txBody>
+          <a:bodyPr wrap="square" anchor="ctr">
+            <a:spAutoFit/>
+          </a:bodyPr>
+          <a:lstStyle/>
+          <a:p>
+            <a:pPr algn="l">
+              <a:spcAft>
+                <a:spcPts val="400"/>
+              </a:spcAft>
+            </a:pPr>
+            <a:r>
+              <a:rPr sz="1150" b="0">
+                <a:solidFill>
+                  <a:srgbClr val="9AA6C8"/>
+                </a:solidFill>
+                <a:latin typeface="Arial"/>
+              </a:rPr>
+              <a:t>$186</a:t>
+            </a:r>
+          </a:p>
+        </p:txBody>
+      </p:sp>
+      <p:sp>
+        <p:nvSpPr>
+          <p:cNvPr id="61" name="Rectangle 60"/>
+          <p:cNvSpPr/>
+          <p:nvPr/>
+        </p:nvSpPr>
+        <p:spPr>
+          <a:xfrm>
+            <a:off x="5009303" y="4123944"/>
+            <a:ext cx="2586566" cy="457200"/>
+          </a:xfrm>
+          <a:prstGeom prst="rect">
+            <a:avLst/>
+          </a:prstGeom>
+          <a:solidFill>
+            <a:srgbClr val="151D38"/>
+          </a:solidFill>
+          <a:ln>
+            <a:noFill/>
+          </a:ln>
+          <a:effectLst/>
+        </p:spPr>
+        <p:style>
+          <a:lnRef idx="1">
+            <a:schemeClr val="accent1"/>
+          </a:lnRef>
+          <a:fillRef idx="3">
+            <a:schemeClr val="accent1"/>
+          </a:fillRef>
+          <a:effectRef idx="2">
+            <a:schemeClr val="accent1"/>
+          </a:effectRef>
+          <a:fontRef idx="minor">
+            <a:schemeClr val="lt1"/>
+          </a:fontRef>
+        </p:style>
+        <p:txBody>
+          <a:bodyPr rtlCol="0" anchor="ctr"/>
+          <a:lstStyle/>
+          <a:p>
+            <a:pPr algn="ctr"/>
+          </a:p>
+        </p:txBody>
+      </p:sp>
+      <p:sp>
+        <p:nvSpPr>
+          <p:cNvPr id="62" name="TextBox 61"/>
+          <p:cNvSpPr txBox="1"/>
+          <p:nvPr/>
+        </p:nvSpPr>
+        <p:spPr>
+          <a:xfrm>
+            <a:off x="5082455" y="4123944"/>
+            <a:ext cx="2440262" cy="457200"/>
+          </a:xfrm>
+          <a:prstGeom prst="rect">
+            <a:avLst/>
+          </a:prstGeom>
+          <a:noFill/>
+        </p:spPr>
+        <p:txBody>
+          <a:bodyPr wrap="square" anchor="ctr">
+            <a:spAutoFit/>
+          </a:bodyPr>
+          <a:lstStyle/>
+          <a:p>
+            <a:pPr algn="l">
+              <a:spcAft>
+                <a:spcPts val="400"/>
+              </a:spcAft>
+            </a:pPr>
+            <a:r>
+              <a:rPr sz="1150" b="0">
+                <a:solidFill>
+                  <a:srgbClr val="9AA6C8"/>
+                </a:solidFill>
+                <a:latin typeface="Arial"/>
+              </a:rPr>
+              <a:t>500 × $5.5 = $2,750</a:t>
+            </a:r>
+          </a:p>
+        </p:txBody>
+      </p:sp>
+      <p:sp>
+        <p:nvSpPr>
+          <p:cNvPr id="63" name="Rectangle 62"/>
+          <p:cNvSpPr/>
+          <p:nvPr/>
+        </p:nvSpPr>
+        <p:spPr>
+          <a:xfrm>
+            <a:off x="7595869" y="4123944"/>
+            <a:ext cx="2387600" cy="457200"/>
+          </a:xfrm>
+          <a:prstGeom prst="rect">
+            <a:avLst/>
+          </a:prstGeom>
+          <a:solidFill>
+            <a:srgbClr val="151D38"/>
+          </a:solidFill>
+          <a:ln>
+            <a:noFill/>
+          </a:ln>
+          <a:effectLst/>
+        </p:spPr>
+        <p:style>
+          <a:lnRef idx="1">
+            <a:schemeClr val="accent1"/>
+          </a:lnRef>
+          <a:fillRef idx="3">
+            <a:schemeClr val="accent1"/>
+          </a:fillRef>
+          <a:effectRef idx="2">
+            <a:schemeClr val="accent1"/>
+          </a:effectRef>
+          <a:fontRef idx="minor">
+            <a:schemeClr val="lt1"/>
+          </a:fontRef>
+        </p:style>
+        <p:txBody>
+          <a:bodyPr rtlCol="0" anchor="ctr"/>
+          <a:lstStyle/>
+          <a:p>
+            <a:pPr algn="ctr"/>
+          </a:p>
+        </p:txBody>
+      </p:sp>
+      <p:sp>
+        <p:nvSpPr>
+          <p:cNvPr id="64" name="TextBox 63"/>
+          <p:cNvSpPr txBox="1"/>
+          <p:nvPr/>
+        </p:nvSpPr>
+        <p:spPr>
+          <a:xfrm>
+            <a:off x="7669021" y="4123944"/>
+            <a:ext cx="2241296" cy="457200"/>
+          </a:xfrm>
+          <a:prstGeom prst="rect">
+            <a:avLst/>
+          </a:prstGeom>
+          <a:noFill/>
+        </p:spPr>
+        <p:txBody>
+          <a:bodyPr wrap="square" anchor="ctr">
+            <a:spAutoFit/>
+          </a:bodyPr>
+          <a:lstStyle/>
+          <a:p>
+            <a:pPr algn="l">
+              <a:spcAft>
+                <a:spcPts val="400"/>
+              </a:spcAft>
+            </a:pPr>
+            <a:r>
+              <a:rPr sz="1150" b="0">
+                <a:solidFill>
+                  <a:srgbClr val="9AA6C8"/>
+                </a:solidFill>
+                <a:latin typeface="Arial"/>
+              </a:rPr>
+              <a:t>≈ $2,936</a:t>
+            </a:r>
+          </a:p>
+        </p:txBody>
+      </p:sp>
+      <p:sp>
+        <p:nvSpPr>
+          <p:cNvPr id="65" name="Rectangle 64"/>
+          <p:cNvSpPr/>
+          <p:nvPr/>
+        </p:nvSpPr>
+        <p:spPr>
+          <a:xfrm>
+            <a:off x="9983469" y="4123944"/>
+            <a:ext cx="1492249" cy="457200"/>
+          </a:xfrm>
+          <a:prstGeom prst="rect">
+            <a:avLst/>
+          </a:prstGeom>
+          <a:solidFill>
+            <a:srgbClr val="151D38"/>
+          </a:solidFill>
+          <a:ln>
+            <a:noFill/>
+          </a:ln>
+          <a:effectLst/>
+        </p:spPr>
+        <p:style>
+          <a:lnRef idx="1">
+            <a:schemeClr val="accent1"/>
+          </a:lnRef>
+          <a:fillRef idx="3">
+            <a:schemeClr val="accent1"/>
+          </a:fillRef>
+          <a:effectRef idx="2">
+            <a:schemeClr val="accent1"/>
+          </a:effectRef>
+          <a:fontRef idx="minor">
+            <a:schemeClr val="lt1"/>
+          </a:fontRef>
+        </p:style>
+        <p:txBody>
+          <a:bodyPr rtlCol="0" anchor="ctr"/>
+          <a:lstStyle/>
+          <a:p>
+            <a:pPr algn="ctr"/>
+          </a:p>
+        </p:txBody>
+      </p:sp>
+      <p:sp>
+        <p:nvSpPr>
+          <p:cNvPr id="66" name="TextBox 65"/>
+          <p:cNvSpPr txBox="1"/>
+          <p:nvPr/>
+        </p:nvSpPr>
+        <p:spPr>
+          <a:xfrm>
+            <a:off x="10056621" y="4123944"/>
+            <a:ext cx="1345945" cy="457200"/>
+          </a:xfrm>
+          <a:prstGeom prst="rect">
+            <a:avLst/>
+          </a:prstGeom>
+          <a:noFill/>
+        </p:spPr>
+        <p:txBody>
+          <a:bodyPr wrap="square" anchor="ctr">
+            <a:spAutoFit/>
+          </a:bodyPr>
+          <a:lstStyle/>
+          <a:p>
+            <a:pPr algn="l">
+              <a:spcAft>
+                <a:spcPts val="400"/>
+              </a:spcAft>
+            </a:pPr>
+            <a:r>
+              <a:rPr sz="1150" b="0">
+                <a:solidFill>
+                  <a:srgbClr val="9AA6C8"/>
+                </a:solidFill>
+                <a:latin typeface="Arial"/>
+              </a:rPr>
               <a:t>≈ $5.9</a:t>
             </a:r>
           </a:p>
@@ -5765,7 +6180,7 @@
       </p:sp>
       <p:sp>
         <p:nvSpPr>
-          <p:cNvPr id="57" name="TextBox 56"/>
+          <p:cNvPr id="67" name="TextBox 66"/>
           <p:cNvSpPr txBox="1"/>
           <p:nvPr/>
         </p:nvSpPr>
@@ -5804,7 +6219,7 @@
       </p:sp>
       <p:sp>
         <p:nvSpPr>
-          <p:cNvPr id="58" name="TextBox 57"/>
+          <p:cNvPr id="68" name="TextBox 67"/>
           <p:cNvSpPr txBox="1"/>
           <p:nvPr/>
         </p:nvSpPr>
@@ -13982,7 +14397,7 @@
                 </a:solidFill>
                 <a:latin typeface="Arial"/>
               </a:rPr>
-              <a:t>Dos tiers, misma imagen</a:t>
+              <a:t>Dos tiers: prueba (barato) y pago (fuerte)</a:t>
             </a:r>
           </a:p>
         </p:txBody>
@@ -14041,8 +14456,8 @@
         </p:nvSpPr>
         <p:spPr>
           <a:xfrm>
-            <a:off x="731520" y="1920240"/>
-            <a:ext cx="2302328" cy="420624"/>
+            <a:off x="731520" y="1783080"/>
+            <a:ext cx="2450431" cy="420624"/>
           </a:xfrm>
           <a:prstGeom prst="rect">
             <a:avLst/>
@@ -14085,8 +14500,8 @@
         </p:nvSpPr>
         <p:spPr>
           <a:xfrm>
-            <a:off x="804672" y="1920240"/>
-            <a:ext cx="2156024" cy="420624"/>
+            <a:off x="804672" y="1783080"/>
+            <a:ext cx="2304127" cy="420624"/>
           </a:xfrm>
           <a:prstGeom prst="rect">
             <a:avLst/>
@@ -14124,8 +14539,8 @@
         </p:nvSpPr>
         <p:spPr>
           <a:xfrm>
-            <a:off x="3033848" y="1920240"/>
-            <a:ext cx="4029075" cy="420624"/>
+            <a:off x="3181951" y="1783080"/>
+            <a:ext cx="4146884" cy="420624"/>
           </a:xfrm>
           <a:prstGeom prst="rect">
             <a:avLst/>
@@ -14168,8 +14583,8 @@
         </p:nvSpPr>
         <p:spPr>
           <a:xfrm>
-            <a:off x="3107000" y="1920240"/>
-            <a:ext cx="3882771" cy="420624"/>
+            <a:off x="3255103" y="1783080"/>
+            <a:ext cx="4000580" cy="420624"/>
           </a:xfrm>
           <a:prstGeom prst="rect">
             <a:avLst/>
@@ -14194,7 +14609,7 @@
                 </a:solidFill>
                 <a:latin typeface="Arial"/>
               </a:rPr>
-              <a:t>Free / Lite</a:t>
+              <a:t>Prueba / Free</a:t>
             </a:r>
           </a:p>
         </p:txBody>
@@ -14207,8 +14622,8 @@
         </p:nvSpPr>
         <p:spPr>
           <a:xfrm>
-            <a:off x="7062923" y="1920240"/>
-            <a:ext cx="4412796" cy="420624"/>
+            <a:off x="7328835" y="1783080"/>
+            <a:ext cx="4146884" cy="420624"/>
           </a:xfrm>
           <a:prstGeom prst="rect">
             <a:avLst/>
@@ -14251,8 +14666,8 @@
         </p:nvSpPr>
         <p:spPr>
           <a:xfrm>
-            <a:off x="7136075" y="1920240"/>
-            <a:ext cx="4266492" cy="420624"/>
+            <a:off x="7401987" y="1783080"/>
+            <a:ext cx="4000580" cy="420624"/>
           </a:xfrm>
           <a:prstGeom prst="rect">
             <a:avLst/>
@@ -14277,7 +14692,7 @@
                 </a:solidFill>
                 <a:latin typeface="Arial"/>
               </a:rPr>
-              <a:t>Pro / Always On</a:t>
+              <a:t>Pago / Pro</a:t>
             </a:r>
           </a:p>
         </p:txBody>
@@ -14290,8 +14705,8 @@
         </p:nvSpPr>
         <p:spPr>
           <a:xfrm>
-            <a:off x="731520" y="2340864"/>
-            <a:ext cx="2302328" cy="548640"/>
+            <a:off x="731520" y="2203704"/>
+            <a:ext cx="2450431" cy="502920"/>
           </a:xfrm>
           <a:prstGeom prst="rect">
             <a:avLst/>
@@ -14334,8 +14749,8 @@
         </p:nvSpPr>
         <p:spPr>
           <a:xfrm>
-            <a:off x="804672" y="2340864"/>
-            <a:ext cx="2156024" cy="548640"/>
+            <a:off x="804672" y="2203704"/>
+            <a:ext cx="2304127" cy="502920"/>
           </a:xfrm>
           <a:prstGeom prst="rect">
             <a:avLst/>
@@ -14373,8 +14788,8 @@
         </p:nvSpPr>
         <p:spPr>
           <a:xfrm>
-            <a:off x="3033848" y="2340864"/>
-            <a:ext cx="4029075" cy="548640"/>
+            <a:off x="3181951" y="2203704"/>
+            <a:ext cx="4146884" cy="502920"/>
           </a:xfrm>
           <a:prstGeom prst="rect">
             <a:avLst/>
@@ -14417,8 +14832,8 @@
         </p:nvSpPr>
         <p:spPr>
           <a:xfrm>
-            <a:off x="3107000" y="2340864"/>
-            <a:ext cx="3882771" cy="548640"/>
+            <a:off x="3255103" y="2203704"/>
+            <a:ext cx="4000580" cy="502920"/>
           </a:xfrm>
           <a:prstGeom prst="rect">
             <a:avLst/>
@@ -14456,8 +14871,8 @@
         </p:nvSpPr>
         <p:spPr>
           <a:xfrm>
-            <a:off x="7062923" y="2340864"/>
-            <a:ext cx="4412796" cy="548640"/>
+            <a:off x="7328835" y="2203704"/>
+            <a:ext cx="4146884" cy="502920"/>
           </a:xfrm>
           <a:prstGeom prst="rect">
             <a:avLst/>
@@ -14500,8 +14915,8 @@
         </p:nvSpPr>
         <p:spPr>
           <a:xfrm>
-            <a:off x="7136075" y="2340864"/>
-            <a:ext cx="4266492" cy="548640"/>
+            <a:off x="7401987" y="2203704"/>
+            <a:ext cx="4000580" cy="502920"/>
           </a:xfrm>
           <a:prstGeom prst="rect">
             <a:avLst/>
@@ -14539,8 +14954,8 @@
         </p:nvSpPr>
         <p:spPr>
           <a:xfrm>
-            <a:off x="731520" y="2889504"/>
-            <a:ext cx="2302328" cy="548640"/>
+            <a:off x="731520" y="2706624"/>
+            <a:ext cx="2450431" cy="502920"/>
           </a:xfrm>
           <a:prstGeom prst="rect">
             <a:avLst/>
@@ -14583,8 +14998,8 @@
         </p:nvSpPr>
         <p:spPr>
           <a:xfrm>
-            <a:off x="804672" y="2889504"/>
-            <a:ext cx="2156024" cy="548640"/>
+            <a:off x="804672" y="2706624"/>
+            <a:ext cx="2304127" cy="502920"/>
           </a:xfrm>
           <a:prstGeom prst="rect">
             <a:avLst/>
@@ -14622,8 +15037,8 @@
         </p:nvSpPr>
         <p:spPr>
           <a:xfrm>
-            <a:off x="3033848" y="2889504"/>
-            <a:ext cx="4029075" cy="548640"/>
+            <a:off x="3181951" y="2706624"/>
+            <a:ext cx="4146884" cy="502920"/>
           </a:xfrm>
           <a:prstGeom prst="rect">
             <a:avLst/>
@@ -14666,8 +15081,8 @@
         </p:nvSpPr>
         <p:spPr>
           <a:xfrm>
-            <a:off x="3107000" y="2889504"/>
-            <a:ext cx="3882771" cy="548640"/>
+            <a:off x="3255103" y="2706624"/>
+            <a:ext cx="4000580" cy="502920"/>
           </a:xfrm>
           <a:prstGeom prst="rect">
             <a:avLst/>
@@ -14705,8 +15120,8 @@
         </p:nvSpPr>
         <p:spPr>
           <a:xfrm>
-            <a:off x="7062923" y="2889504"/>
-            <a:ext cx="4412796" cy="548640"/>
+            <a:off x="7328835" y="2706624"/>
+            <a:ext cx="4146884" cy="502920"/>
           </a:xfrm>
           <a:prstGeom prst="rect">
             <a:avLst/>
@@ -14749,8 +15164,8 @@
         </p:nvSpPr>
         <p:spPr>
           <a:xfrm>
-            <a:off x="7136075" y="2889504"/>
-            <a:ext cx="4266492" cy="548640"/>
+            <a:off x="7401987" y="2706624"/>
+            <a:ext cx="4000580" cy="502920"/>
           </a:xfrm>
           <a:prstGeom prst="rect">
             <a:avLst/>
@@ -14775,7 +15190,7 @@
                 </a:solidFill>
                 <a:latin typeface="Arial"/>
               </a:rPr>
-              <a:t>24/7 (routines), min 1 réplica</a:t>
+              <a:t>24/7 routines, min 1 réplica</a:t>
             </a:r>
           </a:p>
         </p:txBody>
@@ -14788,8 +15203,8 @@
         </p:nvSpPr>
         <p:spPr>
           <a:xfrm>
-            <a:off x="731520" y="3438144"/>
-            <a:ext cx="2302328" cy="548640"/>
+            <a:off x="731520" y="3209544"/>
+            <a:ext cx="2450431" cy="502920"/>
           </a:xfrm>
           <a:prstGeom prst="rect">
             <a:avLst/>
@@ -14832,8 +15247,8 @@
         </p:nvSpPr>
         <p:spPr>
           <a:xfrm>
-            <a:off x="804672" y="3438144"/>
-            <a:ext cx="2156024" cy="548640"/>
+            <a:off x="804672" y="3209544"/>
+            <a:ext cx="2304127" cy="502920"/>
           </a:xfrm>
           <a:prstGeom prst="rect">
             <a:avLst/>
@@ -14871,8 +15286,8 @@
         </p:nvSpPr>
         <p:spPr>
           <a:xfrm>
-            <a:off x="3033848" y="3438144"/>
-            <a:ext cx="4029075" cy="548640"/>
+            <a:off x="3181951" y="3209544"/>
+            <a:ext cx="4146884" cy="502920"/>
           </a:xfrm>
           <a:prstGeom prst="rect">
             <a:avLst/>
@@ -14915,8 +15330,8 @@
         </p:nvSpPr>
         <p:spPr>
           <a:xfrm>
-            <a:off x="3107000" y="3438144"/>
-            <a:ext cx="3882771" cy="548640"/>
+            <a:off x="3255103" y="3209544"/>
+            <a:ext cx="4000580" cy="502920"/>
           </a:xfrm>
           <a:prstGeom prst="rect">
             <a:avLst/>
@@ -14941,7 +15356,7 @@
                 </a:solidFill>
                 <a:latin typeface="Arial"/>
               </a:rPr>
-              <a:t>microVM + gVisor</a:t>
+              <a:t>microVM + gVisor (¡se conserva!)</a:t>
             </a:r>
           </a:p>
         </p:txBody>
@@ -14954,8 +15369,8 @@
         </p:nvSpPr>
         <p:spPr>
           <a:xfrm>
-            <a:off x="7062923" y="3438144"/>
-            <a:ext cx="4412796" cy="548640"/>
+            <a:off x="7328835" y="3209544"/>
+            <a:ext cx="4146884" cy="502920"/>
           </a:xfrm>
           <a:prstGeom prst="rect">
             <a:avLst/>
@@ -14998,8 +15413,8 @@
         </p:nvSpPr>
         <p:spPr>
           <a:xfrm>
-            <a:off x="7136075" y="3438144"/>
-            <a:ext cx="4266492" cy="548640"/>
+            <a:off x="7401987" y="3209544"/>
+            <a:ext cx="4000580" cy="502920"/>
           </a:xfrm>
           <a:prstGeom prst="rect">
             <a:avLst/>
@@ -15037,8 +15452,8 @@
         </p:nvSpPr>
         <p:spPr>
           <a:xfrm>
-            <a:off x="731520" y="3986784"/>
-            <a:ext cx="2302328" cy="548640"/>
+            <a:off x="731520" y="3712463"/>
+            <a:ext cx="2450431" cy="502920"/>
           </a:xfrm>
           <a:prstGeom prst="rect">
             <a:avLst/>
@@ -15081,8 +15496,8 @@
         </p:nvSpPr>
         <p:spPr>
           <a:xfrm>
-            <a:off x="804672" y="3986784"/>
-            <a:ext cx="2156024" cy="548640"/>
+            <a:off x="804672" y="3712463"/>
+            <a:ext cx="2304127" cy="502920"/>
           </a:xfrm>
           <a:prstGeom prst="rect">
             <a:avLst/>
@@ -15120,8 +15535,8 @@
         </p:nvSpPr>
         <p:spPr>
           <a:xfrm>
-            <a:off x="3033848" y="3986784"/>
-            <a:ext cx="4029075" cy="548640"/>
+            <a:off x="3181951" y="3712463"/>
+            <a:ext cx="4146884" cy="502920"/>
           </a:xfrm>
           <a:prstGeom prst="rect">
             <a:avLst/>
@@ -15164,8 +15579,8 @@
         </p:nvSpPr>
         <p:spPr>
           <a:xfrm>
-            <a:off x="3107000" y="3986784"/>
-            <a:ext cx="3882771" cy="548640"/>
+            <a:off x="3255103" y="3712463"/>
+            <a:ext cx="4000580" cy="502920"/>
           </a:xfrm>
           <a:prstGeom prst="rect">
             <a:avLst/>
@@ -15203,8 +15618,8 @@
         </p:nvSpPr>
         <p:spPr>
           <a:xfrm>
-            <a:off x="7062923" y="3986784"/>
-            <a:ext cx="4412796" cy="548640"/>
+            <a:off x="7328835" y="3712463"/>
+            <a:ext cx="4146884" cy="502920"/>
           </a:xfrm>
           <a:prstGeom prst="rect">
             <a:avLst/>
@@ -15247,8 +15662,8 @@
         </p:nvSpPr>
         <p:spPr>
           <a:xfrm>
-            <a:off x="7136075" y="3986784"/>
-            <a:ext cx="4266492" cy="548640"/>
+            <a:off x="7401987" y="3712463"/>
+            <a:ext cx="4000580" cy="502920"/>
           </a:xfrm>
           <a:prstGeom prst="rect">
             <a:avLst/>
@@ -15286,8 +15701,8 @@
         </p:nvSpPr>
         <p:spPr>
           <a:xfrm>
-            <a:off x="731520" y="4535424"/>
-            <a:ext cx="2302328" cy="548640"/>
+            <a:off x="731520" y="4215383"/>
+            <a:ext cx="2450431" cy="502920"/>
           </a:xfrm>
           <a:prstGeom prst="rect">
             <a:avLst/>
@@ -15330,8 +15745,8 @@
         </p:nvSpPr>
         <p:spPr>
           <a:xfrm>
-            <a:off x="804672" y="4535424"/>
-            <a:ext cx="2156024" cy="548640"/>
+            <a:off x="804672" y="4215383"/>
+            <a:ext cx="2304127" cy="502920"/>
           </a:xfrm>
           <a:prstGeom prst="rect">
             <a:avLst/>
@@ -15356,7 +15771,7 @@
                 </a:solidFill>
                 <a:latin typeface="Arial"/>
               </a:rPr>
-              <a:t>Costo p/ nosotros</a:t>
+              <a:t>Infra fija que usa</a:t>
             </a:r>
           </a:p>
         </p:txBody>
@@ -15369,8 +15784,8 @@
         </p:nvSpPr>
         <p:spPr>
           <a:xfrm>
-            <a:off x="3033848" y="4535424"/>
-            <a:ext cx="4029075" cy="548640"/>
+            <a:off x="3181951" y="4215383"/>
+            <a:ext cx="4146884" cy="502920"/>
           </a:xfrm>
           <a:prstGeom prst="rect">
             <a:avLst/>
@@ -15413,8 +15828,8 @@
         </p:nvSpPr>
         <p:spPr>
           <a:xfrm>
-            <a:off x="3107000" y="4535424"/>
-            <a:ext cx="3882771" cy="548640"/>
+            <a:off x="3255103" y="4215383"/>
+            <a:ext cx="4000580" cy="502920"/>
           </a:xfrm>
           <a:prstGeom prst="rect">
             <a:avLst/>
@@ -15439,7 +15854,7 @@
                 </a:solidFill>
                 <a:latin typeface="Arial"/>
               </a:rPr>
-              <a:t>~$0 idle, centavos activo</a:t>
+              <a:t>Solo Cloud Run + Supabase</a:t>
             </a:r>
           </a:p>
         </p:txBody>
@@ -15452,8 +15867,8 @@
         </p:nvSpPr>
         <p:spPr>
           <a:xfrm>
-            <a:off x="7062923" y="4535424"/>
-            <a:ext cx="4412796" cy="548640"/>
+            <a:off x="7328835" y="4215383"/>
+            <a:ext cx="4146884" cy="502920"/>
           </a:xfrm>
           <a:prstGeom prst="rect">
             <a:avLst/>
@@ -15496,8 +15911,8 @@
         </p:nvSpPr>
         <p:spPr>
           <a:xfrm>
-            <a:off x="7136075" y="4535424"/>
-            <a:ext cx="4266492" cy="548640"/>
+            <a:off x="7401987" y="4215383"/>
+            <a:ext cx="4000580" cy="502920"/>
           </a:xfrm>
           <a:prstGeom prst="rect">
             <a:avLst/>
@@ -15522,7 +15937,7 @@
                 </a:solidFill>
                 <a:latin typeface="Arial"/>
               </a:rPr>
-              <a:t>~$5–8 / equipo / mes (infra)</a:t>
+              <a:t>GKE + NAT + Cloud SQL</a:t>
             </a:r>
           </a:p>
         </p:txBody>
@@ -15535,14 +15950,14 @@
         </p:nvSpPr>
         <p:spPr>
           <a:xfrm>
-            <a:off x="731520" y="5532120"/>
-            <a:ext cx="10744200" cy="868680"/>
-          </a:xfrm>
-          <a:prstGeom prst="rect">
-            <a:avLst/>
-          </a:prstGeom>
-          <a:solidFill>
-            <a:srgbClr val="151D38"/>
+            <a:off x="731520" y="4718303"/>
+            <a:ext cx="2450431" cy="502920"/>
+          </a:xfrm>
+          <a:prstGeom prst="rect">
+            <a:avLst/>
+          </a:prstGeom>
+          <a:solidFill>
+            <a:srgbClr val="10162E"/>
           </a:solidFill>
           <a:ln>
             <a:noFill/>
@@ -15573,20 +15988,59 @@
       </p:sp>
       <p:sp>
         <p:nvSpPr>
-          <p:cNvPr id="44" name="Rectangle 43"/>
+          <p:cNvPr id="44" name="TextBox 43"/>
+          <p:cNvSpPr txBox="1"/>
+          <p:nvPr/>
+        </p:nvSpPr>
+        <p:spPr>
+          <a:xfrm>
+            <a:off x="804672" y="4718303"/>
+            <a:ext cx="2304127" cy="502920"/>
+          </a:xfrm>
+          <a:prstGeom prst="rect">
+            <a:avLst/>
+          </a:prstGeom>
+          <a:noFill/>
+        </p:spPr>
+        <p:txBody>
+          <a:bodyPr wrap="square" anchor="ctr">
+            <a:spAutoFit/>
+          </a:bodyPr>
+          <a:lstStyle/>
+          <a:p>
+            <a:pPr algn="l">
+              <a:spcAft>
+                <a:spcPts val="400"/>
+              </a:spcAft>
+            </a:pPr>
+            <a:r>
+              <a:rPr sz="1150" b="1">
+                <a:solidFill>
+                  <a:srgbClr val="EDF1FF"/>
+                </a:solidFill>
+                <a:latin typeface="Arial"/>
+              </a:rPr>
+              <a:t>Costo p/ nosotros</a:t>
+            </a:r>
+          </a:p>
+        </p:txBody>
+      </p:sp>
+      <p:sp>
+        <p:nvSpPr>
+          <p:cNvPr id="45" name="Rectangle 44"/>
           <p:cNvSpPr/>
           <p:nvPr/>
         </p:nvSpPr>
         <p:spPr>
           <a:xfrm>
-            <a:off x="731520" y="5532120"/>
-            <a:ext cx="91440" cy="868680"/>
-          </a:xfrm>
-          <a:prstGeom prst="rect">
-            <a:avLst/>
-          </a:prstGeom>
-          <a:solidFill>
-            <a:srgbClr val="F5A623"/>
+            <a:off x="3181951" y="4718303"/>
+            <a:ext cx="4146884" cy="502920"/>
+          </a:xfrm>
+          <a:prstGeom prst="rect">
+            <a:avLst/>
+          </a:prstGeom>
+          <a:solidFill>
+            <a:srgbClr val="10162E"/>
           </a:solidFill>
           <a:ln>
             <a:noFill/>
@@ -15617,14 +16071,224 @@
       </p:sp>
       <p:sp>
         <p:nvSpPr>
-          <p:cNvPr id="45" name="TextBox 44"/>
+          <p:cNvPr id="46" name="TextBox 45"/>
           <p:cNvSpPr txBox="1"/>
           <p:nvPr/>
         </p:nvSpPr>
         <p:spPr>
           <a:xfrm>
-            <a:off x="1005840" y="5650992"/>
-            <a:ext cx="10241280" cy="731520"/>
+            <a:off x="3255103" y="4718303"/>
+            <a:ext cx="4000580" cy="502920"/>
+          </a:xfrm>
+          <a:prstGeom prst="rect">
+            <a:avLst/>
+          </a:prstGeom>
+          <a:noFill/>
+        </p:spPr>
+        <p:txBody>
+          <a:bodyPr wrap="square" anchor="ctr">
+            <a:spAutoFit/>
+          </a:bodyPr>
+          <a:lstStyle/>
+          <a:p>
+            <a:pPr algn="l">
+              <a:spcAft>
+                <a:spcPts val="400"/>
+              </a:spcAft>
+            </a:pPr>
+            <a:r>
+              <a:rPr sz="1150" b="0">
+                <a:solidFill>
+                  <a:srgbClr val="9AA6C8"/>
+                </a:solidFill>
+                <a:latin typeface="Arial"/>
+              </a:rPr>
+              <a:t>~$0 idle · fijo ~$22/mes</a:t>
+            </a:r>
+          </a:p>
+        </p:txBody>
+      </p:sp>
+      <p:sp>
+        <p:nvSpPr>
+          <p:cNvPr id="47" name="Rectangle 46"/>
+          <p:cNvSpPr/>
+          <p:nvPr/>
+        </p:nvSpPr>
+        <p:spPr>
+          <a:xfrm>
+            <a:off x="7328835" y="4718303"/>
+            <a:ext cx="4146884" cy="502920"/>
+          </a:xfrm>
+          <a:prstGeom prst="rect">
+            <a:avLst/>
+          </a:prstGeom>
+          <a:solidFill>
+            <a:srgbClr val="10162E"/>
+          </a:solidFill>
+          <a:ln>
+            <a:noFill/>
+          </a:ln>
+          <a:effectLst/>
+        </p:spPr>
+        <p:style>
+          <a:lnRef idx="1">
+            <a:schemeClr val="accent1"/>
+          </a:lnRef>
+          <a:fillRef idx="3">
+            <a:schemeClr val="accent1"/>
+          </a:fillRef>
+          <a:effectRef idx="2">
+            <a:schemeClr val="accent1"/>
+          </a:effectRef>
+          <a:fontRef idx="minor">
+            <a:schemeClr val="lt1"/>
+          </a:fontRef>
+        </p:style>
+        <p:txBody>
+          <a:bodyPr rtlCol="0" anchor="ctr"/>
+          <a:lstStyle/>
+          <a:p>
+            <a:pPr algn="ctr"/>
+          </a:p>
+        </p:txBody>
+      </p:sp>
+      <p:sp>
+        <p:nvSpPr>
+          <p:cNvPr id="48" name="TextBox 47"/>
+          <p:cNvSpPr txBox="1"/>
+          <p:nvPr/>
+        </p:nvSpPr>
+        <p:spPr>
+          <a:xfrm>
+            <a:off x="7401987" y="4718303"/>
+            <a:ext cx="4000580" cy="502920"/>
+          </a:xfrm>
+          <a:prstGeom prst="rect">
+            <a:avLst/>
+          </a:prstGeom>
+          <a:noFill/>
+        </p:spPr>
+        <p:txBody>
+          <a:bodyPr wrap="square" anchor="ctr">
+            <a:spAutoFit/>
+          </a:bodyPr>
+          <a:lstStyle/>
+          <a:p>
+            <a:pPr algn="l">
+              <a:spcAft>
+                <a:spcPts val="400"/>
+              </a:spcAft>
+            </a:pPr>
+            <a:r>
+              <a:rPr sz="1150" b="0">
+                <a:solidFill>
+                  <a:srgbClr val="9AA6C8"/>
+                </a:solidFill>
+                <a:latin typeface="Arial"/>
+              </a:rPr>
+              <a:t>~$5–8 /equipo · fijo ~$186</a:t>
+            </a:r>
+          </a:p>
+        </p:txBody>
+      </p:sp>
+      <p:sp>
+        <p:nvSpPr>
+          <p:cNvPr id="49" name="Rectangle 48"/>
+          <p:cNvSpPr/>
+          <p:nvPr/>
+        </p:nvSpPr>
+        <p:spPr>
+          <a:xfrm>
+            <a:off x="731520" y="5669280"/>
+            <a:ext cx="10744200" cy="777240"/>
+          </a:xfrm>
+          <a:prstGeom prst="rect">
+            <a:avLst/>
+          </a:prstGeom>
+          <a:solidFill>
+            <a:srgbClr val="151D38"/>
+          </a:solidFill>
+          <a:ln>
+            <a:noFill/>
+          </a:ln>
+          <a:effectLst/>
+        </p:spPr>
+        <p:style>
+          <a:lnRef idx="1">
+            <a:schemeClr val="accent1"/>
+          </a:lnRef>
+          <a:fillRef idx="3">
+            <a:schemeClr val="accent1"/>
+          </a:fillRef>
+          <a:effectRef idx="2">
+            <a:schemeClr val="accent1"/>
+          </a:effectRef>
+          <a:fontRef idx="minor">
+            <a:schemeClr val="lt1"/>
+          </a:fontRef>
+        </p:style>
+        <p:txBody>
+          <a:bodyPr rtlCol="0" anchor="ctr"/>
+          <a:lstStyle/>
+          <a:p>
+            <a:pPr algn="ctr"/>
+          </a:p>
+        </p:txBody>
+      </p:sp>
+      <p:sp>
+        <p:nvSpPr>
+          <p:cNvPr id="50" name="Rectangle 49"/>
+          <p:cNvSpPr/>
+          <p:nvPr/>
+        </p:nvSpPr>
+        <p:spPr>
+          <a:xfrm>
+            <a:off x="731520" y="5669280"/>
+            <a:ext cx="91440" cy="777240"/>
+          </a:xfrm>
+          <a:prstGeom prst="rect">
+            <a:avLst/>
+          </a:prstGeom>
+          <a:solidFill>
+            <a:srgbClr val="F5A623"/>
+          </a:solidFill>
+          <a:ln>
+            <a:noFill/>
+          </a:ln>
+          <a:effectLst/>
+        </p:spPr>
+        <p:style>
+          <a:lnRef idx="1">
+            <a:schemeClr val="accent1"/>
+          </a:lnRef>
+          <a:fillRef idx="3">
+            <a:schemeClr val="accent1"/>
+          </a:fillRef>
+          <a:effectRef idx="2">
+            <a:schemeClr val="accent1"/>
+          </a:effectRef>
+          <a:fontRef idx="minor">
+            <a:schemeClr val="lt1"/>
+          </a:fontRef>
+        </p:style>
+        <p:txBody>
+          <a:bodyPr rtlCol="0" anchor="ctr"/>
+          <a:lstStyle/>
+          <a:p>
+            <a:pPr algn="ctr"/>
+          </a:p>
+        </p:txBody>
+      </p:sp>
+      <p:sp>
+        <p:nvSpPr>
+          <p:cNvPr id="51" name="TextBox 50"/>
+          <p:cNvSpPr txBox="1"/>
+          <p:nvPr/>
+        </p:nvSpPr>
+        <p:spPr>
+          <a:xfrm>
+            <a:off x="1005840" y="5760720"/>
+            <a:ext cx="10241280" cy="640080"/>
           </a:xfrm>
           <a:prstGeom prst="rect">
             <a:avLst/>
@@ -15643,22 +16307,22 @@
               </a:spcAft>
             </a:pPr>
             <a:r>
-              <a:rPr sz="1350" b="1">
+              <a:rPr sz="1300" b="1">
                 <a:solidFill>
                   <a:srgbClr val="F5A623"/>
                 </a:solidFill>
                 <a:latin typeface="Arial"/>
               </a:rPr>
-              <a:t>Promoción free → pro  </a:t>
-            </a:r>
-            <a:r>
-              <a:rPr sz="1350" b="0">
+              <a:t>Clave del ahorro  </a:t>
+            </a:r>
+            <a:r>
+              <a:rPr sz="1300" b="0">
                 <a:solidFill>
                   <a:srgbClr val="EDF1FF"/>
                 </a:solidFill>
                 <a:latin typeface="Arial"/>
               </a:rPr>
-              <a:t>= mover el volumen entre sustratos. Mismo binario, mismo HOUSTON_HOME, sin migrar datos.</a:t>
+              <a:t>— el tier de prueba quita GKE/NAT/Cloud SQL pero MANTIENE el sandbox de kernel. Promoción free→pro = mover el volumen, sin migrar datos.</a:t>
             </a:r>
           </a:p>
         </p:txBody>
@@ -17524,7 +18188,7 @@
                 </a:solidFill>
                 <a:latin typeface="Arial"/>
               </a:rPr>
-              <a:t>Fijo / compartido (control plane)</a:t>
+              <a:t>Fijo / compartido — Pago vs Prueba</a:t>
             </a:r>
           </a:p>
         </p:txBody>
@@ -17538,7 +18202,7 @@
         <p:spPr>
           <a:xfrm>
             <a:off x="731520" y="2697480"/>
-            <a:ext cx="4046220" cy="393192"/>
+            <a:ext cx="3108959" cy="365760"/>
           </a:xfrm>
           <a:prstGeom prst="rect">
             <a:avLst/>
@@ -17582,7 +18246,7 @@
         <p:spPr>
           <a:xfrm>
             <a:off x="804672" y="2697480"/>
-            <a:ext cx="3899916" cy="393192"/>
+            <a:ext cx="2962655" cy="365760"/>
           </a:xfrm>
           <a:prstGeom prst="rect">
             <a:avLst/>
@@ -17601,7 +18265,7 @@
               </a:spcAft>
             </a:pPr>
             <a:r>
-              <a:rPr sz="1100" b="1">
+              <a:rPr sz="1050" b="1">
                 <a:solidFill>
                   <a:srgbClr val="FFFFFF"/>
                 </a:solidFill>
@@ -17620,8 +18284,8 @@
         </p:nvSpPr>
         <p:spPr>
           <a:xfrm>
-            <a:off x="4777740" y="2697480"/>
-            <a:ext cx="1348740" cy="393192"/>
+            <a:off x="3840479" y="2697480"/>
+            <a:ext cx="1143000" cy="365760"/>
           </a:xfrm>
           <a:prstGeom prst="rect">
             <a:avLst/>
@@ -17664,8 +18328,8 @@
         </p:nvSpPr>
         <p:spPr>
           <a:xfrm>
-            <a:off x="4850892" y="2697480"/>
-            <a:ext cx="1202436" cy="393192"/>
+            <a:off x="3913631" y="2697480"/>
+            <a:ext cx="996696" cy="365760"/>
           </a:xfrm>
           <a:prstGeom prst="rect">
             <a:avLst/>
@@ -17684,13 +18348,13 @@
               </a:spcAft>
             </a:pPr>
             <a:r>
-              <a:rPr sz="1100" b="1">
+              <a:rPr sz="1050" b="1">
                 <a:solidFill>
                   <a:srgbClr val="FFFFFF"/>
                 </a:solidFill>
                 <a:latin typeface="Arial"/>
               </a:rPr>
-              <a:t>USD/mes</a:t>
+              <a:t>Pago</a:t>
             </a:r>
           </a:p>
         </p:txBody>
@@ -17703,14 +18367,14 @@
         </p:nvSpPr>
         <p:spPr>
           <a:xfrm>
-            <a:off x="731520" y="3090672"/>
-            <a:ext cx="4046220" cy="374904"/>
-          </a:xfrm>
-          <a:prstGeom prst="rect">
-            <a:avLst/>
-          </a:prstGeom>
-          <a:solidFill>
-            <a:srgbClr val="151D38"/>
+            <a:off x="4983479" y="2697480"/>
+            <a:ext cx="1143000" cy="365760"/>
+          </a:xfrm>
+          <a:prstGeom prst="rect">
+            <a:avLst/>
+          </a:prstGeom>
+          <a:solidFill>
+            <a:srgbClr val="5B8DEF"/>
           </a:solidFill>
           <a:ln>
             <a:noFill/>
@@ -17747,8 +18411,8 @@
         </p:nvSpPr>
         <p:spPr>
           <a:xfrm>
-            <a:off x="804672" y="3090672"/>
-            <a:ext cx="3899916" cy="374904"/>
+            <a:off x="5056631" y="2697480"/>
+            <a:ext cx="996696" cy="365760"/>
           </a:xfrm>
           <a:prstGeom prst="rect">
             <a:avLst/>
@@ -17767,13 +18431,13 @@
               </a:spcAft>
             </a:pPr>
             <a:r>
-              <a:rPr sz="1100" b="1">
-                <a:solidFill>
-                  <a:srgbClr val="EDF1FF"/>
-                </a:solidFill>
-                <a:latin typeface="Arial"/>
-              </a:rPr>
-              <a:t>GKE cluster management fee</a:t>
+              <a:rPr sz="1050" b="1">
+                <a:solidFill>
+                  <a:srgbClr val="FFFFFF"/>
+                </a:solidFill>
+                <a:latin typeface="Arial"/>
+              </a:rPr>
+              <a:t>Prueba</a:t>
             </a:r>
           </a:p>
         </p:txBody>
@@ -17786,8 +18450,8 @@
         </p:nvSpPr>
         <p:spPr>
           <a:xfrm>
-            <a:off x="4777740" y="3090672"/>
-            <a:ext cx="1348740" cy="374904"/>
+            <a:off x="731520" y="3063240"/>
+            <a:ext cx="3108959" cy="329184"/>
           </a:xfrm>
           <a:prstGeom prst="rect">
             <a:avLst/>
@@ -17830,8 +18494,8 @@
         </p:nvSpPr>
         <p:spPr>
           <a:xfrm>
-            <a:off x="4850892" y="3090672"/>
-            <a:ext cx="1202436" cy="374904"/>
+            <a:off x="804672" y="3063240"/>
+            <a:ext cx="2962655" cy="329184"/>
           </a:xfrm>
           <a:prstGeom prst="rect">
             <a:avLst/>
@@ -17850,13 +18514,13 @@
               </a:spcAft>
             </a:pPr>
             <a:r>
-              <a:rPr sz="1100" b="0">
-                <a:solidFill>
-                  <a:srgbClr val="9AA6C8"/>
-                </a:solidFill>
-                <a:latin typeface="Arial"/>
-              </a:rPr>
-              <a:t>$73</a:t>
+              <a:rPr sz="1050" b="1">
+                <a:solidFill>
+                  <a:srgbClr val="EDF1FF"/>
+                </a:solidFill>
+                <a:latin typeface="Arial"/>
+              </a:rPr>
+              <a:t>GKE cluster fee</a:t>
             </a:r>
           </a:p>
         </p:txBody>
@@ -17869,14 +18533,14 @@
         </p:nvSpPr>
         <p:spPr>
           <a:xfrm>
-            <a:off x="731520" y="3465576"/>
-            <a:ext cx="4046220" cy="374904"/>
-          </a:xfrm>
-          <a:prstGeom prst="rect">
-            <a:avLst/>
-          </a:prstGeom>
-          <a:solidFill>
-            <a:srgbClr val="10162E"/>
+            <a:off x="3840479" y="3063240"/>
+            <a:ext cx="1143000" cy="329184"/>
+          </a:xfrm>
+          <a:prstGeom prst="rect">
+            <a:avLst/>
+          </a:prstGeom>
+          <a:solidFill>
+            <a:srgbClr val="151D38"/>
           </a:solidFill>
           <a:ln>
             <a:noFill/>
@@ -17913,8 +18577,8 @@
         </p:nvSpPr>
         <p:spPr>
           <a:xfrm>
-            <a:off x="804672" y="3465576"/>
-            <a:ext cx="3899916" cy="374904"/>
+            <a:off x="3913631" y="3063240"/>
+            <a:ext cx="996696" cy="329184"/>
           </a:xfrm>
           <a:prstGeom prst="rect">
             <a:avLst/>
@@ -17933,13 +18597,13 @@
               </a:spcAft>
             </a:pPr>
             <a:r>
-              <a:rPr sz="1100" b="1">
-                <a:solidFill>
-                  <a:srgbClr val="EDF1FF"/>
-                </a:solidFill>
-                <a:latin typeface="Arial"/>
-              </a:rPr>
-              <a:t>Cloud SQL (control plane)</a:t>
+              <a:rPr sz="1050" b="0">
+                <a:solidFill>
+                  <a:srgbClr val="9AA6C8"/>
+                </a:solidFill>
+                <a:latin typeface="Arial"/>
+              </a:rPr>
+              <a:t>$73</a:t>
             </a:r>
           </a:p>
         </p:txBody>
@@ -17952,14 +18616,14 @@
         </p:nvSpPr>
         <p:spPr>
           <a:xfrm>
-            <a:off x="4777740" y="3465576"/>
-            <a:ext cx="1348740" cy="374904"/>
-          </a:xfrm>
-          <a:prstGeom prst="rect">
-            <a:avLst/>
-          </a:prstGeom>
-          <a:solidFill>
-            <a:srgbClr val="10162E"/>
+            <a:off x="4983479" y="3063240"/>
+            <a:ext cx="1143000" cy="329184"/>
+          </a:xfrm>
+          <a:prstGeom prst="rect">
+            <a:avLst/>
+          </a:prstGeom>
+          <a:solidFill>
+            <a:srgbClr val="151D38"/>
           </a:solidFill>
           <a:ln>
             <a:noFill/>
@@ -17996,8 +18660,8 @@
         </p:nvSpPr>
         <p:spPr>
           <a:xfrm>
-            <a:off x="4850892" y="3465576"/>
-            <a:ext cx="1202436" cy="374904"/>
+            <a:off x="5056631" y="3063240"/>
+            <a:ext cx="996696" cy="329184"/>
           </a:xfrm>
           <a:prstGeom prst="rect">
             <a:avLst/>
@@ -18016,13 +18680,13 @@
               </a:spcAft>
             </a:pPr>
             <a:r>
-              <a:rPr sz="1100" b="0">
+              <a:rPr sz="1050" b="0">
                 <a:solidFill>
                   <a:srgbClr val="9AA6C8"/>
                 </a:solidFill>
                 <a:latin typeface="Arial"/>
               </a:rPr>
-              <a:t>$35</a:t>
+              <a:t>—</a:t>
             </a:r>
           </a:p>
         </p:txBody>
@@ -18035,14 +18699,14 @@
         </p:nvSpPr>
         <p:spPr>
           <a:xfrm>
-            <a:off x="731520" y="3840480"/>
-            <a:ext cx="4046220" cy="374904"/>
-          </a:xfrm>
-          <a:prstGeom prst="rect">
-            <a:avLst/>
-          </a:prstGeom>
-          <a:solidFill>
-            <a:srgbClr val="151D38"/>
+            <a:off x="731520" y="3392424"/>
+            <a:ext cx="3108959" cy="329184"/>
+          </a:xfrm>
+          <a:prstGeom prst="rect">
+            <a:avLst/>
+          </a:prstGeom>
+          <a:solidFill>
+            <a:srgbClr val="10162E"/>
           </a:solidFill>
           <a:ln>
             <a:noFill/>
@@ -18079,8 +18743,8 @@
         </p:nvSpPr>
         <p:spPr>
           <a:xfrm>
-            <a:off x="804672" y="3840480"/>
-            <a:ext cx="3899916" cy="374904"/>
+            <a:off x="804672" y="3392424"/>
+            <a:ext cx="2962655" cy="329184"/>
           </a:xfrm>
           <a:prstGeom prst="rect">
             <a:avLst/>
@@ -18099,13 +18763,13 @@
               </a:spcAft>
             </a:pPr>
             <a:r>
-              <a:rPr sz="1100" b="1">
+              <a:rPr sz="1050" b="1">
                 <a:solidFill>
                   <a:srgbClr val="EDF1FF"/>
                 </a:solidFill>
                 <a:latin typeface="Arial"/>
               </a:rPr>
-              <a:t>Gateway + control plane (Cloud Run)</a:t>
+              <a:t>Cloud SQL (control plane)</a:t>
             </a:r>
           </a:p>
         </p:txBody>
@@ -18118,14 +18782,14 @@
         </p:nvSpPr>
         <p:spPr>
           <a:xfrm>
-            <a:off x="4777740" y="3840480"/>
-            <a:ext cx="1348740" cy="374904"/>
-          </a:xfrm>
-          <a:prstGeom prst="rect">
-            <a:avLst/>
-          </a:prstGeom>
-          <a:solidFill>
-            <a:srgbClr val="151D38"/>
+            <a:off x="3840479" y="3392424"/>
+            <a:ext cx="1143000" cy="329184"/>
+          </a:xfrm>
+          <a:prstGeom prst="rect">
+            <a:avLst/>
+          </a:prstGeom>
+          <a:solidFill>
+            <a:srgbClr val="10162E"/>
           </a:solidFill>
           <a:ln>
             <a:noFill/>
@@ -18162,8 +18826,8 @@
         </p:nvSpPr>
         <p:spPr>
           <a:xfrm>
-            <a:off x="4850892" y="3840480"/>
-            <a:ext cx="1202436" cy="374904"/>
+            <a:off x="3913631" y="3392424"/>
+            <a:ext cx="996696" cy="329184"/>
           </a:xfrm>
           <a:prstGeom prst="rect">
             <a:avLst/>
@@ -18182,13 +18846,13 @@
               </a:spcAft>
             </a:pPr>
             <a:r>
-              <a:rPr sz="1100" b="0">
+              <a:rPr sz="1050" b="0">
                 <a:solidFill>
                   <a:srgbClr val="9AA6C8"/>
                 </a:solidFill>
                 <a:latin typeface="Arial"/>
               </a:rPr>
-              <a:t>$20</a:t>
+              <a:t>$35</a:t>
             </a:r>
           </a:p>
         </p:txBody>
@@ -18201,8 +18865,8 @@
         </p:nvSpPr>
         <p:spPr>
           <a:xfrm>
-            <a:off x="731520" y="4215384"/>
-            <a:ext cx="4046220" cy="374904"/>
+            <a:off x="4983479" y="3392424"/>
+            <a:ext cx="1143000" cy="329184"/>
           </a:xfrm>
           <a:prstGeom prst="rect">
             <a:avLst/>
@@ -18245,8 +18909,8 @@
         </p:nvSpPr>
         <p:spPr>
           <a:xfrm>
-            <a:off x="804672" y="4215384"/>
-            <a:ext cx="3899916" cy="374904"/>
+            <a:off x="5056631" y="3392424"/>
+            <a:ext cx="996696" cy="329184"/>
           </a:xfrm>
           <a:prstGeom prst="rect">
             <a:avLst/>
@@ -18265,13 +18929,13 @@
               </a:spcAft>
             </a:pPr>
             <a:r>
-              <a:rPr sz="1100" b="1">
-                <a:solidFill>
-                  <a:srgbClr val="EDF1FF"/>
-                </a:solidFill>
-                <a:latin typeface="Arial"/>
-              </a:rPr>
-              <a:t>Cloud NAT</a:t>
+              <a:rPr sz="1050" b="0">
+                <a:solidFill>
+                  <a:srgbClr val="9AA6C8"/>
+                </a:solidFill>
+                <a:latin typeface="Arial"/>
+              </a:rPr>
+              <a:t>—</a:t>
             </a:r>
           </a:p>
         </p:txBody>
@@ -18284,14 +18948,14 @@
         </p:nvSpPr>
         <p:spPr>
           <a:xfrm>
-            <a:off x="4777740" y="4215384"/>
-            <a:ext cx="1348740" cy="374904"/>
-          </a:xfrm>
-          <a:prstGeom prst="rect">
-            <a:avLst/>
-          </a:prstGeom>
-          <a:solidFill>
-            <a:srgbClr val="10162E"/>
+            <a:off x="731520" y="3721608"/>
+            <a:ext cx="3108959" cy="329184"/>
+          </a:xfrm>
+          <a:prstGeom prst="rect">
+            <a:avLst/>
+          </a:prstGeom>
+          <a:solidFill>
+            <a:srgbClr val="151D38"/>
           </a:solidFill>
           <a:ln>
             <a:noFill/>
@@ -18328,8 +18992,8 @@
         </p:nvSpPr>
         <p:spPr>
           <a:xfrm>
-            <a:off x="4850892" y="4215384"/>
-            <a:ext cx="1202436" cy="374904"/>
+            <a:off x="804672" y="3721608"/>
+            <a:ext cx="2962655" cy="329184"/>
           </a:xfrm>
           <a:prstGeom prst="rect">
             <a:avLst/>
@@ -18348,13 +19012,13 @@
               </a:spcAft>
             </a:pPr>
             <a:r>
-              <a:rPr sz="1100" b="0">
-                <a:solidFill>
-                  <a:srgbClr val="9AA6C8"/>
-                </a:solidFill>
-                <a:latin typeface="Arial"/>
-              </a:rPr>
-              <a:t>$33</a:t>
+              <a:rPr sz="1050" b="1">
+                <a:solidFill>
+                  <a:srgbClr val="EDF1FF"/>
+                </a:solidFill>
+                <a:latin typeface="Arial"/>
+              </a:rPr>
+              <a:t>Cloud NAT</a:t>
             </a:r>
           </a:p>
         </p:txBody>
@@ -18367,8 +19031,8 @@
         </p:nvSpPr>
         <p:spPr>
           <a:xfrm>
-            <a:off x="731520" y="4590288"/>
-            <a:ext cx="4046220" cy="374904"/>
+            <a:off x="3840479" y="3721608"/>
+            <a:ext cx="1143000" cy="329184"/>
           </a:xfrm>
           <a:prstGeom prst="rect">
             <a:avLst/>
@@ -18411,8 +19075,8 @@
         </p:nvSpPr>
         <p:spPr>
           <a:xfrm>
-            <a:off x="804672" y="4590288"/>
-            <a:ext cx="3899916" cy="374904"/>
+            <a:off x="3913631" y="3721608"/>
+            <a:ext cx="996696" cy="329184"/>
           </a:xfrm>
           <a:prstGeom prst="rect">
             <a:avLst/>
@@ -18431,13 +19095,13 @@
               </a:spcAft>
             </a:pPr>
             <a:r>
-              <a:rPr sz="1100" b="1">
-                <a:solidFill>
-                  <a:srgbClr val="EDF1FF"/>
-                </a:solidFill>
-                <a:latin typeface="Arial"/>
-              </a:rPr>
-              <a:t>Logging / Monitoring / Audit</a:t>
+              <a:rPr sz="1050" b="0">
+                <a:solidFill>
+                  <a:srgbClr val="9AA6C8"/>
+                </a:solidFill>
+                <a:latin typeface="Arial"/>
+              </a:rPr>
+              <a:t>$33</a:t>
             </a:r>
           </a:p>
         </p:txBody>
@@ -18450,8 +19114,8 @@
         </p:nvSpPr>
         <p:spPr>
           <a:xfrm>
-            <a:off x="4777740" y="4590288"/>
-            <a:ext cx="1348740" cy="374904"/>
+            <a:off x="4983479" y="3721608"/>
+            <a:ext cx="1143000" cy="329184"/>
           </a:xfrm>
           <a:prstGeom prst="rect">
             <a:avLst/>
@@ -18494,8 +19158,8 @@
         </p:nvSpPr>
         <p:spPr>
           <a:xfrm>
-            <a:off x="4850892" y="4590288"/>
-            <a:ext cx="1202436" cy="374904"/>
+            <a:off x="5056631" y="3721608"/>
+            <a:ext cx="996696" cy="329184"/>
           </a:xfrm>
           <a:prstGeom prst="rect">
             <a:avLst/>
@@ -18514,13 +19178,13 @@
               </a:spcAft>
             </a:pPr>
             <a:r>
-              <a:rPr sz="1100" b="0">
+              <a:rPr sz="1050" b="0">
                 <a:solidFill>
                   <a:srgbClr val="9AA6C8"/>
                 </a:solidFill>
                 <a:latin typeface="Arial"/>
               </a:rPr>
-              <a:t>$20</a:t>
+              <a:t>—</a:t>
             </a:r>
           </a:p>
         </p:txBody>
@@ -18533,8 +19197,8 @@
         </p:nvSpPr>
         <p:spPr>
           <a:xfrm>
-            <a:off x="731520" y="4965192"/>
-            <a:ext cx="4046220" cy="374904"/>
+            <a:off x="731520" y="4050792"/>
+            <a:ext cx="3108959" cy="329184"/>
           </a:xfrm>
           <a:prstGeom prst="rect">
             <a:avLst/>
@@ -18577,8 +19241,8 @@
         </p:nvSpPr>
         <p:spPr>
           <a:xfrm>
-            <a:off x="804672" y="4965192"/>
-            <a:ext cx="3899916" cy="374904"/>
+            <a:off x="804672" y="4050792"/>
+            <a:ext cx="2962655" cy="329184"/>
           </a:xfrm>
           <a:prstGeom prst="rect">
             <a:avLst/>
@@ -18597,13 +19261,13 @@
               </a:spcAft>
             </a:pPr>
             <a:r>
-              <a:rPr sz="1100" b="1">
+              <a:rPr sz="1050" b="1">
                 <a:solidFill>
                   <a:srgbClr val="EDF1FF"/>
                 </a:solidFill>
                 <a:latin typeface="Arial"/>
               </a:rPr>
-              <a:t>Secret Manager + misc</a:t>
+              <a:t>Gateway + control plane (CR)</a:t>
             </a:r>
           </a:p>
         </p:txBody>
@@ -18616,8 +19280,8 @@
         </p:nvSpPr>
         <p:spPr>
           <a:xfrm>
-            <a:off x="4777740" y="4965192"/>
-            <a:ext cx="1348740" cy="374904"/>
+            <a:off x="3840479" y="4050792"/>
+            <a:ext cx="1143000" cy="329184"/>
           </a:xfrm>
           <a:prstGeom prst="rect">
             <a:avLst/>
@@ -18660,8 +19324,8 @@
         </p:nvSpPr>
         <p:spPr>
           <a:xfrm>
-            <a:off x="4850892" y="4965192"/>
-            <a:ext cx="1202436" cy="374904"/>
+            <a:off x="3913631" y="4050792"/>
+            <a:ext cx="996696" cy="329184"/>
           </a:xfrm>
           <a:prstGeom prst="rect">
             <a:avLst/>
@@ -18680,13 +19344,13 @@
               </a:spcAft>
             </a:pPr>
             <a:r>
-              <a:rPr sz="1100" b="0">
+              <a:rPr sz="1050" b="0">
                 <a:solidFill>
                   <a:srgbClr val="9AA6C8"/>
                 </a:solidFill>
                 <a:latin typeface="Arial"/>
               </a:rPr>
-              <a:t>$5</a:t>
+              <a:t>$20</a:t>
             </a:r>
           </a:p>
         </p:txBody>
@@ -18699,14 +19363,14 @@
         </p:nvSpPr>
         <p:spPr>
           <a:xfrm>
-            <a:off x="731520" y="5340096"/>
-            <a:ext cx="4046220" cy="374904"/>
-          </a:xfrm>
-          <a:prstGeom prst="rect">
-            <a:avLst/>
-          </a:prstGeom>
-          <a:solidFill>
-            <a:srgbClr val="151D38"/>
+            <a:off x="4983479" y="4050792"/>
+            <a:ext cx="1143000" cy="329184"/>
+          </a:xfrm>
+          <a:prstGeom prst="rect">
+            <a:avLst/>
+          </a:prstGeom>
+          <a:solidFill>
+            <a:srgbClr val="10162E"/>
           </a:solidFill>
           <a:ln>
             <a:noFill/>
@@ -18743,8 +19407,8 @@
         </p:nvSpPr>
         <p:spPr>
           <a:xfrm>
-            <a:off x="804672" y="5340096"/>
-            <a:ext cx="3899916" cy="374904"/>
+            <a:off x="5056631" y="4050792"/>
+            <a:ext cx="996696" cy="329184"/>
           </a:xfrm>
           <a:prstGeom prst="rect">
             <a:avLst/>
@@ -18763,13 +19427,13 @@
               </a:spcAft>
             </a:pPr>
             <a:r>
-              <a:rPr sz="1100" b="1">
-                <a:solidFill>
-                  <a:srgbClr val="EDF1FF"/>
-                </a:solidFill>
-                <a:latin typeface="Arial"/>
-              </a:rPr>
-              <a:t>TOTAL FIJO</a:t>
+              <a:rPr sz="1050" b="0">
+                <a:solidFill>
+                  <a:srgbClr val="9AA6C8"/>
+                </a:solidFill>
+                <a:latin typeface="Arial"/>
+              </a:rPr>
+              <a:t>$15</a:t>
             </a:r>
           </a:p>
         </p:txBody>
@@ -18782,8 +19446,8 @@
         </p:nvSpPr>
         <p:spPr>
           <a:xfrm>
-            <a:off x="4777740" y="5340096"/>
-            <a:ext cx="1348740" cy="374904"/>
+            <a:off x="731520" y="4379976"/>
+            <a:ext cx="3108959" cy="329184"/>
           </a:xfrm>
           <a:prstGeom prst="rect">
             <a:avLst/>
@@ -18826,8 +19490,8 @@
         </p:nvSpPr>
         <p:spPr>
           <a:xfrm>
-            <a:off x="4850892" y="5340096"/>
-            <a:ext cx="1202436" cy="374904"/>
+            <a:off x="804672" y="4379976"/>
+            <a:ext cx="2962655" cy="329184"/>
           </a:xfrm>
           <a:prstGeom prst="rect">
             <a:avLst/>
@@ -18846,72 +19510,33 @@
               </a:spcAft>
             </a:pPr>
             <a:r>
-              <a:rPr sz="1100" b="0">
-                <a:solidFill>
-                  <a:srgbClr val="9AA6C8"/>
-                </a:solidFill>
-                <a:latin typeface="Arial"/>
-              </a:rPr>
-              <a:t>≈ $186</a:t>
-            </a:r>
-          </a:p>
-        </p:txBody>
-      </p:sp>
-      <p:sp>
-        <p:nvSpPr>
-          <p:cNvPr id="41" name="TextBox 40"/>
-          <p:cNvSpPr txBox="1"/>
-          <p:nvPr/>
-        </p:nvSpPr>
-        <p:spPr>
-          <a:xfrm>
-            <a:off x="6400800" y="2286000"/>
-            <a:ext cx="5029200" cy="365760"/>
-          </a:xfrm>
-          <a:prstGeom prst="rect">
-            <a:avLst/>
-          </a:prstGeom>
-          <a:noFill/>
-        </p:spPr>
-        <p:txBody>
-          <a:bodyPr wrap="square" anchor="t">
-            <a:spAutoFit/>
-          </a:bodyPr>
-          <a:lstStyle/>
-          <a:p>
-            <a:pPr algn="l">
-              <a:spcAft>
-                <a:spcPts val="400"/>
-              </a:spcAft>
-            </a:pPr>
-            <a:r>
-              <a:rPr sz="1500" b="1">
-                <a:solidFill>
-                  <a:srgbClr val="F5A623"/>
-                </a:solidFill>
-                <a:latin typeface="Arial"/>
-              </a:rPr>
-              <a:t>Variable por equipo (infra, sin API)</a:t>
-            </a:r>
-          </a:p>
-        </p:txBody>
-      </p:sp>
-      <p:sp>
-        <p:nvSpPr>
-          <p:cNvPr id="42" name="Rectangle 41"/>
+              <a:rPr sz="1050" b="1">
+                <a:solidFill>
+                  <a:srgbClr val="EDF1FF"/>
+                </a:solidFill>
+                <a:latin typeface="Arial"/>
+              </a:rPr>
+              <a:t>Supabase (metadata)</a:t>
+            </a:r>
+          </a:p>
+        </p:txBody>
+      </p:sp>
+      <p:sp>
+        <p:nvSpPr>
+          <p:cNvPr id="41" name="Rectangle 40"/>
           <p:cNvSpPr/>
           <p:nvPr/>
         </p:nvSpPr>
         <p:spPr>
           <a:xfrm>
-            <a:off x="6400800" y="2697480"/>
-            <a:ext cx="2537460" cy="393192"/>
-          </a:xfrm>
-          <a:prstGeom prst="rect">
-            <a:avLst/>
-          </a:prstGeom>
-          <a:solidFill>
-            <a:srgbClr val="3DD598"/>
+            <a:off x="3840479" y="4379976"/>
+            <a:ext cx="1143000" cy="329184"/>
+          </a:xfrm>
+          <a:prstGeom prst="rect">
+            <a:avLst/>
+          </a:prstGeom>
+          <a:solidFill>
+            <a:srgbClr val="151D38"/>
           </a:solidFill>
           <a:ln>
             <a:noFill/>
@@ -18942,14 +19567,14 @@
       </p:sp>
       <p:sp>
         <p:nvSpPr>
-          <p:cNvPr id="43" name="TextBox 42"/>
+          <p:cNvPr id="42" name="TextBox 41"/>
           <p:cNvSpPr txBox="1"/>
           <p:nvPr/>
         </p:nvSpPr>
         <p:spPr>
           <a:xfrm>
-            <a:off x="6473952" y="2697480"/>
-            <a:ext cx="2391156" cy="393192"/>
+            <a:off x="3913631" y="4379976"/>
+            <a:ext cx="996696" cy="329184"/>
           </a:xfrm>
           <a:prstGeom prst="rect">
             <a:avLst/>
@@ -18968,33 +19593,33 @@
               </a:spcAft>
             </a:pPr>
             <a:r>
-              <a:rPr sz="1100" b="1">
-                <a:solidFill>
-                  <a:srgbClr val="FFFFFF"/>
-                </a:solidFill>
-                <a:latin typeface="Arial"/>
-              </a:rPr>
-              <a:t>Concepto</a:t>
-            </a:r>
-          </a:p>
-        </p:txBody>
-      </p:sp>
-      <p:sp>
-        <p:nvSpPr>
-          <p:cNvPr id="44" name="Rectangle 43"/>
+              <a:rPr sz="1050" b="0">
+                <a:solidFill>
+                  <a:srgbClr val="9AA6C8"/>
+                </a:solidFill>
+                <a:latin typeface="Arial"/>
+              </a:rPr>
+              <a:t>incl.</a:t>
+            </a:r>
+          </a:p>
+        </p:txBody>
+      </p:sp>
+      <p:sp>
+        <p:nvSpPr>
+          <p:cNvPr id="43" name="Rectangle 42"/>
           <p:cNvSpPr/>
           <p:nvPr/>
         </p:nvSpPr>
         <p:spPr>
           <a:xfrm>
-            <a:off x="8938260" y="2697480"/>
-            <a:ext cx="1268730" cy="393192"/>
-          </a:xfrm>
-          <a:prstGeom prst="rect">
-            <a:avLst/>
-          </a:prstGeom>
-          <a:solidFill>
-            <a:srgbClr val="3DD598"/>
+            <a:off x="4983479" y="4379976"/>
+            <a:ext cx="1143000" cy="329184"/>
+          </a:xfrm>
+          <a:prstGeom prst="rect">
+            <a:avLst/>
+          </a:prstGeom>
+          <a:solidFill>
+            <a:srgbClr val="151D38"/>
           </a:solidFill>
           <a:ln>
             <a:noFill/>
@@ -19025,14 +19650,14 @@
       </p:sp>
       <p:sp>
         <p:nvSpPr>
-          <p:cNvPr id="45" name="TextBox 44"/>
+          <p:cNvPr id="44" name="TextBox 43"/>
           <p:cNvSpPr txBox="1"/>
           <p:nvPr/>
         </p:nvSpPr>
         <p:spPr>
           <a:xfrm>
-            <a:off x="9011412" y="2697480"/>
-            <a:ext cx="1122426" cy="393192"/>
+            <a:off x="5056631" y="4379976"/>
+            <a:ext cx="996696" cy="329184"/>
           </a:xfrm>
           <a:prstGeom prst="rect">
             <a:avLst/>
@@ -19051,33 +19676,33 @@
               </a:spcAft>
             </a:pPr>
             <a:r>
-              <a:rPr sz="1100" b="1">
-                <a:solidFill>
-                  <a:srgbClr val="FFFFFF"/>
-                </a:solidFill>
-                <a:latin typeface="Arial"/>
-              </a:rPr>
-              <a:t>Pro 24/7</a:t>
-            </a:r>
-          </a:p>
-        </p:txBody>
-      </p:sp>
-      <p:sp>
-        <p:nvSpPr>
-          <p:cNvPr id="46" name="Rectangle 45"/>
+              <a:rPr sz="1050" b="0">
+                <a:solidFill>
+                  <a:srgbClr val="9AA6C8"/>
+                </a:solidFill>
+                <a:latin typeface="Arial"/>
+              </a:rPr>
+              <a:t>$0*</a:t>
+            </a:r>
+          </a:p>
+        </p:txBody>
+      </p:sp>
+      <p:sp>
+        <p:nvSpPr>
+          <p:cNvPr id="45" name="Rectangle 44"/>
           <p:cNvSpPr/>
           <p:nvPr/>
         </p:nvSpPr>
         <p:spPr>
           <a:xfrm>
-            <a:off x="10206990" y="2697480"/>
-            <a:ext cx="1268730" cy="393192"/>
-          </a:xfrm>
-          <a:prstGeom prst="rect">
-            <a:avLst/>
-          </a:prstGeom>
-          <a:solidFill>
-            <a:srgbClr val="3DD598"/>
+            <a:off x="731520" y="4709160"/>
+            <a:ext cx="3108959" cy="329184"/>
+          </a:xfrm>
+          <a:prstGeom prst="rect">
+            <a:avLst/>
+          </a:prstGeom>
+          <a:solidFill>
+            <a:srgbClr val="10162E"/>
           </a:solidFill>
           <a:ln>
             <a:noFill/>
@@ -19108,14 +19733,14 @@
       </p:sp>
       <p:sp>
         <p:nvSpPr>
-          <p:cNvPr id="47" name="TextBox 46"/>
+          <p:cNvPr id="46" name="TextBox 45"/>
           <p:cNvSpPr txBox="1"/>
           <p:nvPr/>
         </p:nvSpPr>
         <p:spPr>
           <a:xfrm>
-            <a:off x="10280142" y="2697480"/>
-            <a:ext cx="1122426" cy="393192"/>
+            <a:off x="804672" y="4709160"/>
+            <a:ext cx="2962655" cy="329184"/>
           </a:xfrm>
           <a:prstGeom prst="rect">
             <a:avLst/>
@@ -19134,33 +19759,33 @@
               </a:spcAft>
             </a:pPr>
             <a:r>
-              <a:rPr sz="1100" b="1">
-                <a:solidFill>
-                  <a:srgbClr val="FFFFFF"/>
-                </a:solidFill>
-                <a:latin typeface="Arial"/>
-              </a:rPr>
-              <a:t>Free</a:t>
-            </a:r>
-          </a:p>
-        </p:txBody>
-      </p:sp>
-      <p:sp>
-        <p:nvSpPr>
-          <p:cNvPr id="48" name="Rectangle 47"/>
+              <a:rPr sz="1050" b="1">
+                <a:solidFill>
+                  <a:srgbClr val="EDF1FF"/>
+                </a:solidFill>
+                <a:latin typeface="Arial"/>
+              </a:rPr>
+              <a:t>Logging / Monitoring</a:t>
+            </a:r>
+          </a:p>
+        </p:txBody>
+      </p:sp>
+      <p:sp>
+        <p:nvSpPr>
+          <p:cNvPr id="47" name="Rectangle 46"/>
           <p:cNvSpPr/>
           <p:nvPr/>
         </p:nvSpPr>
         <p:spPr>
           <a:xfrm>
-            <a:off x="6400800" y="3090672"/>
-            <a:ext cx="2537460" cy="374904"/>
-          </a:xfrm>
-          <a:prstGeom prst="rect">
-            <a:avLst/>
-          </a:prstGeom>
-          <a:solidFill>
-            <a:srgbClr val="151D38"/>
+            <a:off x="3840479" y="4709160"/>
+            <a:ext cx="1143000" cy="329184"/>
+          </a:xfrm>
+          <a:prstGeom prst="rect">
+            <a:avLst/>
+          </a:prstGeom>
+          <a:solidFill>
+            <a:srgbClr val="10162E"/>
           </a:solidFill>
           <a:ln>
             <a:noFill/>
@@ -19191,14 +19816,14 @@
       </p:sp>
       <p:sp>
         <p:nvSpPr>
-          <p:cNvPr id="49" name="TextBox 48"/>
+          <p:cNvPr id="48" name="TextBox 47"/>
           <p:cNvSpPr txBox="1"/>
           <p:nvPr/>
         </p:nvSpPr>
         <p:spPr>
           <a:xfrm>
-            <a:off x="6473952" y="3090672"/>
-            <a:ext cx="2391156" cy="374904"/>
+            <a:off x="3913631" y="4709160"/>
+            <a:ext cx="996696" cy="329184"/>
           </a:xfrm>
           <a:prstGeom prst="rect">
             <a:avLst/>
@@ -19217,33 +19842,33 @@
               </a:spcAft>
             </a:pPr>
             <a:r>
-              <a:rPr sz="1100" b="1">
-                <a:solidFill>
-                  <a:srgbClr val="EDF1FF"/>
-                </a:solidFill>
-                <a:latin typeface="Arial"/>
-              </a:rPr>
-              <a:t>Cómputo (Spot/CR)</a:t>
-            </a:r>
-          </a:p>
-        </p:txBody>
-      </p:sp>
-      <p:sp>
-        <p:nvSpPr>
-          <p:cNvPr id="50" name="Rectangle 49"/>
+              <a:rPr sz="1050" b="0">
+                <a:solidFill>
+                  <a:srgbClr val="9AA6C8"/>
+                </a:solidFill>
+                <a:latin typeface="Arial"/>
+              </a:rPr>
+              <a:t>$20</a:t>
+            </a:r>
+          </a:p>
+        </p:txBody>
+      </p:sp>
+      <p:sp>
+        <p:nvSpPr>
+          <p:cNvPr id="49" name="Rectangle 48"/>
           <p:cNvSpPr/>
           <p:nvPr/>
         </p:nvSpPr>
         <p:spPr>
           <a:xfrm>
-            <a:off x="8938260" y="3090672"/>
-            <a:ext cx="1268730" cy="374904"/>
-          </a:xfrm>
-          <a:prstGeom prst="rect">
-            <a:avLst/>
-          </a:prstGeom>
-          <a:solidFill>
-            <a:srgbClr val="151D38"/>
+            <a:off x="4983479" y="4709160"/>
+            <a:ext cx="1143000" cy="329184"/>
+          </a:xfrm>
+          <a:prstGeom prst="rect">
+            <a:avLst/>
+          </a:prstGeom>
+          <a:solidFill>
+            <a:srgbClr val="10162E"/>
           </a:solidFill>
           <a:ln>
             <a:noFill/>
@@ -19274,14 +19899,14 @@
       </p:sp>
       <p:sp>
         <p:nvSpPr>
-          <p:cNvPr id="51" name="TextBox 50"/>
+          <p:cNvPr id="50" name="TextBox 49"/>
           <p:cNvSpPr txBox="1"/>
           <p:nvPr/>
         </p:nvSpPr>
         <p:spPr>
           <a:xfrm>
-            <a:off x="9011412" y="3090672"/>
-            <a:ext cx="1122426" cy="374904"/>
+            <a:off x="5056631" y="4709160"/>
+            <a:ext cx="996696" cy="329184"/>
           </a:xfrm>
           <a:prstGeom prst="rect">
             <a:avLst/>
@@ -19300,27 +19925,27 @@
               </a:spcAft>
             </a:pPr>
             <a:r>
-              <a:rPr sz="1100" b="0">
+              <a:rPr sz="1050" b="0">
                 <a:solidFill>
                   <a:srgbClr val="9AA6C8"/>
                 </a:solidFill>
                 <a:latin typeface="Arial"/>
               </a:rPr>
-              <a:t>$3.0</a:t>
-            </a:r>
-          </a:p>
-        </p:txBody>
-      </p:sp>
-      <p:sp>
-        <p:nvSpPr>
-          <p:cNvPr id="52" name="Rectangle 51"/>
+              <a:t>$5</a:t>
+            </a:r>
+          </a:p>
+        </p:txBody>
+      </p:sp>
+      <p:sp>
+        <p:nvSpPr>
+          <p:cNvPr id="51" name="Rectangle 50"/>
           <p:cNvSpPr/>
           <p:nvPr/>
         </p:nvSpPr>
         <p:spPr>
           <a:xfrm>
-            <a:off x="10206990" y="3090672"/>
-            <a:ext cx="1268730" cy="374904"/>
+            <a:off x="731520" y="5038344"/>
+            <a:ext cx="3108959" cy="329184"/>
           </a:xfrm>
           <a:prstGeom prst="rect">
             <a:avLst/>
@@ -19357,14 +19982,14 @@
       </p:sp>
       <p:sp>
         <p:nvSpPr>
-          <p:cNvPr id="53" name="TextBox 52"/>
+          <p:cNvPr id="52" name="TextBox 51"/>
           <p:cNvSpPr txBox="1"/>
           <p:nvPr/>
         </p:nvSpPr>
         <p:spPr>
           <a:xfrm>
-            <a:off x="10280142" y="3090672"/>
-            <a:ext cx="1122426" cy="374904"/>
+            <a:off x="804672" y="5038344"/>
+            <a:ext cx="2962655" cy="329184"/>
           </a:xfrm>
           <a:prstGeom prst="rect">
             <a:avLst/>
@@ -19383,33 +20008,33 @@
               </a:spcAft>
             </a:pPr>
             <a:r>
-              <a:rPr sz="1100" b="0">
-                <a:solidFill>
-                  <a:srgbClr val="9AA6C8"/>
-                </a:solidFill>
-                <a:latin typeface="Arial"/>
-              </a:rPr>
-              <a:t>$0–2</a:t>
-            </a:r>
-          </a:p>
-        </p:txBody>
-      </p:sp>
-      <p:sp>
-        <p:nvSpPr>
-          <p:cNvPr id="54" name="Rectangle 53"/>
+              <a:rPr sz="1050" b="1">
+                <a:solidFill>
+                  <a:srgbClr val="EDF1FF"/>
+                </a:solidFill>
+                <a:latin typeface="Arial"/>
+              </a:rPr>
+              <a:t>Secret Manager + misc</a:t>
+            </a:r>
+          </a:p>
+        </p:txBody>
+      </p:sp>
+      <p:sp>
+        <p:nvSpPr>
+          <p:cNvPr id="53" name="Rectangle 52"/>
           <p:cNvSpPr/>
           <p:nvPr/>
         </p:nvSpPr>
         <p:spPr>
           <a:xfrm>
-            <a:off x="6400800" y="3465576"/>
-            <a:ext cx="2537460" cy="374904"/>
-          </a:xfrm>
-          <a:prstGeom prst="rect">
-            <a:avLst/>
-          </a:prstGeom>
-          <a:solidFill>
-            <a:srgbClr val="10162E"/>
+            <a:off x="3840479" y="5038344"/>
+            <a:ext cx="1143000" cy="329184"/>
+          </a:xfrm>
+          <a:prstGeom prst="rect">
+            <a:avLst/>
+          </a:prstGeom>
+          <a:solidFill>
+            <a:srgbClr val="151D38"/>
           </a:solidFill>
           <a:ln>
             <a:noFill/>
@@ -19440,14 +20065,14 @@
       </p:sp>
       <p:sp>
         <p:nvSpPr>
-          <p:cNvPr id="55" name="TextBox 54"/>
+          <p:cNvPr id="54" name="TextBox 53"/>
           <p:cNvSpPr txBox="1"/>
           <p:nvPr/>
         </p:nvSpPr>
         <p:spPr>
           <a:xfrm>
-            <a:off x="6473952" y="3465576"/>
-            <a:ext cx="2391156" cy="374904"/>
+            <a:off x="3913631" y="5038344"/>
+            <a:ext cx="996696" cy="329184"/>
           </a:xfrm>
           <a:prstGeom prst="rect">
             <a:avLst/>
@@ -19466,33 +20091,33 @@
               </a:spcAft>
             </a:pPr>
             <a:r>
-              <a:rPr sz="1100" b="1">
-                <a:solidFill>
-                  <a:srgbClr val="EDF1FF"/>
-                </a:solidFill>
-                <a:latin typeface="Arial"/>
-              </a:rPr>
-              <a:t>Storage GCS</a:t>
-            </a:r>
-          </a:p>
-        </p:txBody>
-      </p:sp>
-      <p:sp>
-        <p:nvSpPr>
-          <p:cNvPr id="56" name="Rectangle 55"/>
+              <a:rPr sz="1050" b="0">
+                <a:solidFill>
+                  <a:srgbClr val="9AA6C8"/>
+                </a:solidFill>
+                <a:latin typeface="Arial"/>
+              </a:rPr>
+              <a:t>$5</a:t>
+            </a:r>
+          </a:p>
+        </p:txBody>
+      </p:sp>
+      <p:sp>
+        <p:nvSpPr>
+          <p:cNvPr id="55" name="Rectangle 54"/>
           <p:cNvSpPr/>
           <p:nvPr/>
         </p:nvSpPr>
         <p:spPr>
           <a:xfrm>
-            <a:off x="8938260" y="3465576"/>
-            <a:ext cx="1268730" cy="374904"/>
-          </a:xfrm>
-          <a:prstGeom prst="rect">
-            <a:avLst/>
-          </a:prstGeom>
-          <a:solidFill>
-            <a:srgbClr val="10162E"/>
+            <a:off x="4983479" y="5038344"/>
+            <a:ext cx="1143000" cy="329184"/>
+          </a:xfrm>
+          <a:prstGeom prst="rect">
+            <a:avLst/>
+          </a:prstGeom>
+          <a:solidFill>
+            <a:srgbClr val="151D38"/>
           </a:solidFill>
           <a:ln>
             <a:noFill/>
@@ -19523,14 +20148,14 @@
       </p:sp>
       <p:sp>
         <p:nvSpPr>
-          <p:cNvPr id="57" name="TextBox 56"/>
+          <p:cNvPr id="56" name="TextBox 55"/>
           <p:cNvSpPr txBox="1"/>
           <p:nvPr/>
         </p:nvSpPr>
         <p:spPr>
           <a:xfrm>
-            <a:off x="9011412" y="3465576"/>
-            <a:ext cx="1122426" cy="374904"/>
+            <a:off x="5056631" y="5038344"/>
+            <a:ext cx="996696" cy="329184"/>
           </a:xfrm>
           <a:prstGeom prst="rect">
             <a:avLst/>
@@ -19549,27 +20174,27 @@
               </a:spcAft>
             </a:pPr>
             <a:r>
-              <a:rPr sz="1100" b="0">
+              <a:rPr sz="1050" b="0">
                 <a:solidFill>
                   <a:srgbClr val="9AA6C8"/>
                 </a:solidFill>
                 <a:latin typeface="Arial"/>
               </a:rPr>
-              <a:t>$0.30</a:t>
-            </a:r>
-          </a:p>
-        </p:txBody>
-      </p:sp>
-      <p:sp>
-        <p:nvSpPr>
-          <p:cNvPr id="58" name="Rectangle 57"/>
+              <a:t>$2</a:t>
+            </a:r>
+          </a:p>
+        </p:txBody>
+      </p:sp>
+      <p:sp>
+        <p:nvSpPr>
+          <p:cNvPr id="57" name="Rectangle 56"/>
           <p:cNvSpPr/>
           <p:nvPr/>
         </p:nvSpPr>
         <p:spPr>
           <a:xfrm>
-            <a:off x="10206990" y="3465576"/>
-            <a:ext cx="1268730" cy="374904"/>
+            <a:off x="731520" y="5367528"/>
+            <a:ext cx="3108959" cy="329184"/>
           </a:xfrm>
           <a:prstGeom prst="rect">
             <a:avLst/>
@@ -19606,14 +20231,14 @@
       </p:sp>
       <p:sp>
         <p:nvSpPr>
-          <p:cNvPr id="59" name="TextBox 58"/>
+          <p:cNvPr id="58" name="TextBox 57"/>
           <p:cNvSpPr txBox="1"/>
           <p:nvPr/>
         </p:nvSpPr>
         <p:spPr>
           <a:xfrm>
-            <a:off x="10280142" y="3465576"/>
-            <a:ext cx="1122426" cy="374904"/>
+            <a:off x="804672" y="5367528"/>
+            <a:ext cx="2962655" cy="329184"/>
           </a:xfrm>
           <a:prstGeom prst="rect">
             <a:avLst/>
@@ -19632,33 +20257,33 @@
               </a:spcAft>
             </a:pPr>
             <a:r>
-              <a:rPr sz="1100" b="0">
-                <a:solidFill>
-                  <a:srgbClr val="9AA6C8"/>
-                </a:solidFill>
-                <a:latin typeface="Arial"/>
-              </a:rPr>
-              <a:t>$0.10</a:t>
-            </a:r>
-          </a:p>
-        </p:txBody>
-      </p:sp>
-      <p:sp>
-        <p:nvSpPr>
-          <p:cNvPr id="60" name="Rectangle 59"/>
+              <a:rPr sz="1050" b="1">
+                <a:solidFill>
+                  <a:srgbClr val="EDF1FF"/>
+                </a:solidFill>
+                <a:latin typeface="Arial"/>
+              </a:rPr>
+              <a:t>TOTAL FIJO</a:t>
+            </a:r>
+          </a:p>
+        </p:txBody>
+      </p:sp>
+      <p:sp>
+        <p:nvSpPr>
+          <p:cNvPr id="59" name="Rectangle 58"/>
           <p:cNvSpPr/>
           <p:nvPr/>
         </p:nvSpPr>
         <p:spPr>
           <a:xfrm>
-            <a:off x="6400800" y="3840480"/>
-            <a:ext cx="2537460" cy="374904"/>
-          </a:xfrm>
-          <a:prstGeom prst="rect">
-            <a:avLst/>
-          </a:prstGeom>
-          <a:solidFill>
-            <a:srgbClr val="151D38"/>
+            <a:off x="3840479" y="5367528"/>
+            <a:ext cx="1143000" cy="329184"/>
+          </a:xfrm>
+          <a:prstGeom prst="rect">
+            <a:avLst/>
+          </a:prstGeom>
+          <a:solidFill>
+            <a:srgbClr val="10162E"/>
           </a:solidFill>
           <a:ln>
             <a:noFill/>
@@ -19689,14 +20314,14 @@
       </p:sp>
       <p:sp>
         <p:nvSpPr>
-          <p:cNvPr id="61" name="TextBox 60"/>
+          <p:cNvPr id="60" name="TextBox 59"/>
           <p:cNvSpPr txBox="1"/>
           <p:nvPr/>
         </p:nvSpPr>
         <p:spPr>
           <a:xfrm>
-            <a:off x="6473952" y="3840480"/>
-            <a:ext cx="2391156" cy="374904"/>
+            <a:off x="3913631" y="5367528"/>
+            <a:ext cx="996696" cy="329184"/>
           </a:xfrm>
           <a:prstGeom prst="rect">
             <a:avLst/>
@@ -19715,33 +20340,33 @@
               </a:spcAft>
             </a:pPr>
             <a:r>
-              <a:rPr sz="1100" b="1">
-                <a:solidFill>
-                  <a:srgbClr val="EDF1FF"/>
-                </a:solidFill>
-                <a:latin typeface="Arial"/>
-              </a:rPr>
-              <a:t>NAT / egress datos</a:t>
-            </a:r>
-          </a:p>
-        </p:txBody>
-      </p:sp>
-      <p:sp>
-        <p:nvSpPr>
-          <p:cNvPr id="62" name="Rectangle 61"/>
+              <a:rPr sz="1050" b="0">
+                <a:solidFill>
+                  <a:srgbClr val="9AA6C8"/>
+                </a:solidFill>
+                <a:latin typeface="Arial"/>
+              </a:rPr>
+              <a:t>≈ $186</a:t>
+            </a:r>
+          </a:p>
+        </p:txBody>
+      </p:sp>
+      <p:sp>
+        <p:nvSpPr>
+          <p:cNvPr id="61" name="Rectangle 60"/>
           <p:cNvSpPr/>
           <p:nvPr/>
         </p:nvSpPr>
         <p:spPr>
           <a:xfrm>
-            <a:off x="8938260" y="3840480"/>
-            <a:ext cx="1268730" cy="374904"/>
-          </a:xfrm>
-          <a:prstGeom prst="rect">
-            <a:avLst/>
-          </a:prstGeom>
-          <a:solidFill>
-            <a:srgbClr val="151D38"/>
+            <a:off x="4983479" y="5367528"/>
+            <a:ext cx="1143000" cy="329184"/>
+          </a:xfrm>
+          <a:prstGeom prst="rect">
+            <a:avLst/>
+          </a:prstGeom>
+          <a:solidFill>
+            <a:srgbClr val="10162E"/>
           </a:solidFill>
           <a:ln>
             <a:noFill/>
@@ -19772,14 +20397,53 @@
       </p:sp>
       <p:sp>
         <p:nvSpPr>
+          <p:cNvPr id="62" name="TextBox 61"/>
+          <p:cNvSpPr txBox="1"/>
+          <p:nvPr/>
+        </p:nvSpPr>
+        <p:spPr>
+          <a:xfrm>
+            <a:off x="5056631" y="5367528"/>
+            <a:ext cx="996696" cy="329184"/>
+          </a:xfrm>
+          <a:prstGeom prst="rect">
+            <a:avLst/>
+          </a:prstGeom>
+          <a:noFill/>
+        </p:spPr>
+        <p:txBody>
+          <a:bodyPr wrap="square" anchor="ctr">
+            <a:spAutoFit/>
+          </a:bodyPr>
+          <a:lstStyle/>
+          <a:p>
+            <a:pPr algn="l">
+              <a:spcAft>
+                <a:spcPts val="400"/>
+              </a:spcAft>
+            </a:pPr>
+            <a:r>
+              <a:rPr sz="1050" b="0">
+                <a:solidFill>
+                  <a:srgbClr val="9AA6C8"/>
+                </a:solidFill>
+                <a:latin typeface="Arial"/>
+              </a:rPr>
+              <a:t>≈ $22</a:t>
+            </a:r>
+          </a:p>
+        </p:txBody>
+      </p:sp>
+      <p:sp>
+        <p:nvSpPr>
           <p:cNvPr id="63" name="TextBox 62"/>
           <p:cNvSpPr txBox="1"/>
           <p:nvPr/>
         </p:nvSpPr>
         <p:spPr>
           <a:xfrm>
-            <a:off x="9011412" y="3840480"/>
-            <a:ext cx="1122426" cy="374904"/>
+            <a:off x="6400800" y="2286000"/>
+            <a:ext cx="5029200" cy="365760"/>
           </a:xfrm>
           <a:prstGeom prst="rect">
             <a:avLst/>
@@ -19787,7 +20451,7 @@
           <a:noFill/>
         </p:spPr>
         <p:txBody>
-          <a:bodyPr wrap="square" anchor="ctr">
+          <a:bodyPr wrap="square" anchor="t">
             <a:spAutoFit/>
           </a:bodyPr>
           <a:lstStyle/>
@@ -19798,13 +20462,13 @@
               </a:spcAft>
             </a:pPr>
             <a:r>
-              <a:rPr sz="1100" b="0">
-                <a:solidFill>
-                  <a:srgbClr val="9AA6C8"/>
-                </a:solidFill>
-                <a:latin typeface="Arial"/>
-              </a:rPr>
-              <a:t>$1.0</a:t>
+              <a:rPr sz="1500" b="1">
+                <a:solidFill>
+                  <a:srgbClr val="F5A623"/>
+                </a:solidFill>
+                <a:latin typeface="Arial"/>
+              </a:rPr>
+              <a:t>Variable por equipo (infra, sin API)</a:t>
             </a:r>
           </a:p>
         </p:txBody>
@@ -19817,14 +20481,14 @@
         </p:nvSpPr>
         <p:spPr>
           <a:xfrm>
-            <a:off x="10206990" y="3840480"/>
-            <a:ext cx="1268730" cy="374904"/>
-          </a:xfrm>
-          <a:prstGeom prst="rect">
-            <a:avLst/>
-          </a:prstGeom>
-          <a:solidFill>
-            <a:srgbClr val="151D38"/>
+            <a:off x="6400800" y="2697480"/>
+            <a:ext cx="2537460" cy="393192"/>
+          </a:xfrm>
+          <a:prstGeom prst="rect">
+            <a:avLst/>
+          </a:prstGeom>
+          <a:solidFill>
+            <a:srgbClr val="3DD598"/>
           </a:solidFill>
           <a:ln>
             <a:noFill/>
@@ -19861,8 +20525,8 @@
         </p:nvSpPr>
         <p:spPr>
           <a:xfrm>
-            <a:off x="10280142" y="3840480"/>
-            <a:ext cx="1122426" cy="374904"/>
+            <a:off x="6473952" y="2697480"/>
+            <a:ext cx="2391156" cy="393192"/>
           </a:xfrm>
           <a:prstGeom prst="rect">
             <a:avLst/>
@@ -19881,13 +20545,13 @@
               </a:spcAft>
             </a:pPr>
             <a:r>
-              <a:rPr sz="1100" b="0">
-                <a:solidFill>
-                  <a:srgbClr val="9AA6C8"/>
-                </a:solidFill>
-                <a:latin typeface="Arial"/>
-              </a:rPr>
-              <a:t>~$0</a:t>
+              <a:rPr sz="1100" b="1">
+                <a:solidFill>
+                  <a:srgbClr val="FFFFFF"/>
+                </a:solidFill>
+                <a:latin typeface="Arial"/>
+              </a:rPr>
+              <a:t>Concepto</a:t>
             </a:r>
           </a:p>
         </p:txBody>
@@ -19900,14 +20564,14 @@
         </p:nvSpPr>
         <p:spPr>
           <a:xfrm>
-            <a:off x="6400800" y="4215384"/>
-            <a:ext cx="2537460" cy="374904"/>
-          </a:xfrm>
-          <a:prstGeom prst="rect">
-            <a:avLst/>
-          </a:prstGeom>
-          <a:solidFill>
-            <a:srgbClr val="10162E"/>
+            <a:off x="8938260" y="2697480"/>
+            <a:ext cx="1268730" cy="393192"/>
+          </a:xfrm>
+          <a:prstGeom prst="rect">
+            <a:avLst/>
+          </a:prstGeom>
+          <a:solidFill>
+            <a:srgbClr val="3DD598"/>
           </a:solidFill>
           <a:ln>
             <a:noFill/>
@@ -19944,8 +20608,8 @@
         </p:nvSpPr>
         <p:spPr>
           <a:xfrm>
-            <a:off x="6473952" y="4215384"/>
-            <a:ext cx="2391156" cy="374904"/>
+            <a:off x="9011412" y="2697480"/>
+            <a:ext cx="1122426" cy="393192"/>
           </a:xfrm>
           <a:prstGeom prst="rect">
             <a:avLst/>
@@ -19966,11 +20630,11 @@
             <a:r>
               <a:rPr sz="1100" b="1">
                 <a:solidFill>
-                  <a:srgbClr val="EDF1FF"/>
-                </a:solidFill>
-                <a:latin typeface="Arial"/>
-              </a:rPr>
-              <a:t>Logs / secrets / misc</a:t>
+                  <a:srgbClr val="FFFFFF"/>
+                </a:solidFill>
+                <a:latin typeface="Arial"/>
+              </a:rPr>
+              <a:t>Pro 24/7</a:t>
             </a:r>
           </a:p>
         </p:txBody>
@@ -19983,14 +20647,14 @@
         </p:nvSpPr>
         <p:spPr>
           <a:xfrm>
-            <a:off x="8938260" y="4215384"/>
-            <a:ext cx="1268730" cy="374904"/>
-          </a:xfrm>
-          <a:prstGeom prst="rect">
-            <a:avLst/>
-          </a:prstGeom>
-          <a:solidFill>
-            <a:srgbClr val="10162E"/>
+            <a:off x="10206990" y="2697480"/>
+            <a:ext cx="1268730" cy="393192"/>
+          </a:xfrm>
+          <a:prstGeom prst="rect">
+            <a:avLst/>
+          </a:prstGeom>
+          <a:solidFill>
+            <a:srgbClr val="3DD598"/>
           </a:solidFill>
           <a:ln>
             <a:noFill/>
@@ -20027,8 +20691,8 @@
         </p:nvSpPr>
         <p:spPr>
           <a:xfrm>
-            <a:off x="9011412" y="4215384"/>
-            <a:ext cx="1122426" cy="374904"/>
+            <a:off x="10280142" y="2697480"/>
+            <a:ext cx="1122426" cy="393192"/>
           </a:xfrm>
           <a:prstGeom prst="rect">
             <a:avLst/>
@@ -20047,13 +20711,13 @@
               </a:spcAft>
             </a:pPr>
             <a:r>
-              <a:rPr sz="1100" b="0">
-                <a:solidFill>
-                  <a:srgbClr val="9AA6C8"/>
-                </a:solidFill>
-                <a:latin typeface="Arial"/>
-              </a:rPr>
-              <a:t>$0.70</a:t>
+              <a:rPr sz="1100" b="1">
+                <a:solidFill>
+                  <a:srgbClr val="FFFFFF"/>
+                </a:solidFill>
+                <a:latin typeface="Arial"/>
+              </a:rPr>
+              <a:t>Free</a:t>
             </a:r>
           </a:p>
         </p:txBody>
@@ -20066,14 +20730,14 @@
         </p:nvSpPr>
         <p:spPr>
           <a:xfrm>
-            <a:off x="10206990" y="4215384"/>
-            <a:ext cx="1268730" cy="374904"/>
-          </a:xfrm>
-          <a:prstGeom prst="rect">
-            <a:avLst/>
-          </a:prstGeom>
-          <a:solidFill>
-            <a:srgbClr val="10162E"/>
+            <a:off x="6400800" y="3090672"/>
+            <a:ext cx="2537460" cy="374904"/>
+          </a:xfrm>
+          <a:prstGeom prst="rect">
+            <a:avLst/>
+          </a:prstGeom>
+          <a:solidFill>
+            <a:srgbClr val="151D38"/>
           </a:solidFill>
           <a:ln>
             <a:noFill/>
@@ -20110,8 +20774,8 @@
         </p:nvSpPr>
         <p:spPr>
           <a:xfrm>
-            <a:off x="10280142" y="4215384"/>
-            <a:ext cx="1122426" cy="374904"/>
+            <a:off x="6473952" y="3090672"/>
+            <a:ext cx="2391156" cy="374904"/>
           </a:xfrm>
           <a:prstGeom prst="rect">
             <a:avLst/>
@@ -20130,13 +20794,13 @@
               </a:spcAft>
             </a:pPr>
             <a:r>
-              <a:rPr sz="1100" b="0">
-                <a:solidFill>
-                  <a:srgbClr val="9AA6C8"/>
-                </a:solidFill>
-                <a:latin typeface="Arial"/>
-              </a:rPr>
-              <a:t>~$0</a:t>
+              <a:rPr sz="1100" b="1">
+                <a:solidFill>
+                  <a:srgbClr val="EDF1FF"/>
+                </a:solidFill>
+                <a:latin typeface="Arial"/>
+              </a:rPr>
+              <a:t>Cómputo (Spot/CR)</a:t>
             </a:r>
           </a:p>
         </p:txBody>
@@ -20149,8 +20813,8 @@
         </p:nvSpPr>
         <p:spPr>
           <a:xfrm>
-            <a:off x="6400800" y="4590288"/>
-            <a:ext cx="2537460" cy="374904"/>
+            <a:off x="8938260" y="3090672"/>
+            <a:ext cx="1268730" cy="374904"/>
           </a:xfrm>
           <a:prstGeom prst="rect">
             <a:avLst/>
@@ -20193,8 +20857,8 @@
         </p:nvSpPr>
         <p:spPr>
           <a:xfrm>
-            <a:off x="6473952" y="4590288"/>
-            <a:ext cx="2391156" cy="374904"/>
+            <a:off x="9011412" y="3090672"/>
+            <a:ext cx="1122426" cy="374904"/>
           </a:xfrm>
           <a:prstGeom prst="rect">
             <a:avLst/>
@@ -20213,13 +20877,13 @@
               </a:spcAft>
             </a:pPr>
             <a:r>
-              <a:rPr sz="1100" b="1">
-                <a:solidFill>
-                  <a:srgbClr val="EDF1FF"/>
-                </a:solidFill>
-                <a:latin typeface="Arial"/>
-              </a:rPr>
-              <a:t>POR EQUIPO</a:t>
+              <a:rPr sz="1100" b="0">
+                <a:solidFill>
+                  <a:srgbClr val="9AA6C8"/>
+                </a:solidFill>
+                <a:latin typeface="Arial"/>
+              </a:rPr>
+              <a:t>$3.0</a:t>
             </a:r>
           </a:p>
         </p:txBody>
@@ -20232,7 +20896,7 @@
         </p:nvSpPr>
         <p:spPr>
           <a:xfrm>
-            <a:off x="8938260" y="4590288"/>
+            <a:off x="10206990" y="3090672"/>
             <a:ext cx="1268730" cy="374904"/>
           </a:xfrm>
           <a:prstGeom prst="rect">
@@ -20276,7 +20940,7 @@
         </p:nvSpPr>
         <p:spPr>
           <a:xfrm>
-            <a:off x="9011412" y="4590288"/>
+            <a:off x="10280142" y="3090672"/>
             <a:ext cx="1122426" cy="374904"/>
           </a:xfrm>
           <a:prstGeom prst="rect">
@@ -20302,7 +20966,7 @@
                 </a:solidFill>
                 <a:latin typeface="Arial"/>
               </a:rPr>
-              <a:t>≈ $5–8</a:t>
+              <a:t>$0–2</a:t>
             </a:r>
           </a:p>
         </p:txBody>
@@ -20315,14 +20979,14 @@
         </p:nvSpPr>
         <p:spPr>
           <a:xfrm>
-            <a:off x="10206990" y="4590288"/>
-            <a:ext cx="1268730" cy="374904"/>
-          </a:xfrm>
-          <a:prstGeom prst="rect">
-            <a:avLst/>
-          </a:prstGeom>
-          <a:solidFill>
-            <a:srgbClr val="151D38"/>
+            <a:off x="6400800" y="3465576"/>
+            <a:ext cx="2537460" cy="374904"/>
+          </a:xfrm>
+          <a:prstGeom prst="rect">
+            <a:avLst/>
+          </a:prstGeom>
+          <a:solidFill>
+            <a:srgbClr val="10162E"/>
           </a:solidFill>
           <a:ln>
             <a:noFill/>
@@ -20359,8 +21023,8 @@
         </p:nvSpPr>
         <p:spPr>
           <a:xfrm>
-            <a:off x="10280142" y="4590288"/>
-            <a:ext cx="1122426" cy="374904"/>
+            <a:off x="6473952" y="3465576"/>
+            <a:ext cx="2391156" cy="374904"/>
           </a:xfrm>
           <a:prstGeom prst="rect">
             <a:avLst/>
@@ -20379,13 +21043,13 @@
               </a:spcAft>
             </a:pPr>
             <a:r>
-              <a:rPr sz="1100" b="0">
-                <a:solidFill>
-                  <a:srgbClr val="9AA6C8"/>
-                </a:solidFill>
-                <a:latin typeface="Arial"/>
-              </a:rPr>
-              <a:t>≈ $0–2</a:t>
+              <a:rPr sz="1100" b="1">
+                <a:solidFill>
+                  <a:srgbClr val="EDF1FF"/>
+                </a:solidFill>
+                <a:latin typeface="Arial"/>
+              </a:rPr>
+              <a:t>Storage GCS</a:t>
             </a:r>
           </a:p>
         </p:txBody>
@@ -20398,14 +21062,14 @@
         </p:nvSpPr>
         <p:spPr>
           <a:xfrm>
-            <a:off x="6400800" y="5440680"/>
-            <a:ext cx="5074920" cy="1051560"/>
-          </a:xfrm>
-          <a:prstGeom prst="rect">
-            <a:avLst/>
-          </a:prstGeom>
-          <a:solidFill>
-            <a:srgbClr val="151D38"/>
+            <a:off x="8938260" y="3465576"/>
+            <a:ext cx="1268730" cy="374904"/>
+          </a:xfrm>
+          <a:prstGeom prst="rect">
+            <a:avLst/>
+          </a:prstGeom>
+          <a:solidFill>
+            <a:srgbClr val="10162E"/>
           </a:solidFill>
           <a:ln>
             <a:noFill/>
@@ -20442,8 +21106,8 @@
         </p:nvSpPr>
         <p:spPr>
           <a:xfrm>
-            <a:off x="6583680" y="5532120"/>
-            <a:ext cx="4754880" cy="914400"/>
+            <a:off x="9011412" y="3465576"/>
+            <a:ext cx="1122426" cy="374904"/>
           </a:xfrm>
           <a:prstGeom prst="rect">
             <a:avLst/>
@@ -20451,7 +21115,7 @@
           <a:noFill/>
         </p:spPr>
         <p:txBody>
-          <a:bodyPr wrap="square" anchor="t">
+          <a:bodyPr wrap="square" anchor="ctr">
             <a:spAutoFit/>
           </a:bodyPr>
           <a:lstStyle/>
@@ -20462,22 +21126,13 @@
               </a:spcAft>
             </a:pPr>
             <a:r>
-              <a:rPr sz="1200" b="1">
-                <a:solidFill>
-                  <a:srgbClr val="F5A623"/>
-                </a:solidFill>
-                <a:latin typeface="Arial"/>
-              </a:rPr>
-              <a:t>API LLM:  </a:t>
-            </a:r>
-            <a:r>
-              <a:rPr sz="1200" b="0">
+              <a:rPr sz="1100" b="0">
                 <a:solidFill>
                   <a:srgbClr val="9AA6C8"/>
                 </a:solidFill>
                 <a:latin typeface="Arial"/>
               </a:rPr>
-              <a:t>Free = BYO (costo $0 para nosotros).  Pro = pass-through + markup → ingreso positivo, no costo neto.</a:t>
+              <a:t>$0.30</a:t>
             </a:r>
           </a:p>
         </p:txBody>
@@ -20490,14 +21145,14 @@
         </p:nvSpPr>
         <p:spPr>
           <a:xfrm>
-            <a:off x="731520" y="5943600"/>
-            <a:ext cx="5394960" cy="548640"/>
-          </a:xfrm>
-          <a:prstGeom prst="rect">
-            <a:avLst/>
-          </a:prstGeom>
-          <a:solidFill>
-            <a:srgbClr val="151D38"/>
+            <a:off x="10206990" y="3465576"/>
+            <a:ext cx="1268730" cy="374904"/>
+          </a:xfrm>
+          <a:prstGeom prst="rect">
+            <a:avLst/>
+          </a:prstGeom>
+          <a:solidFill>
+            <a:srgbClr val="10162E"/>
           </a:solidFill>
           <a:ln>
             <a:noFill/>
@@ -20534,8 +21189,838 @@
         </p:nvSpPr>
         <p:spPr>
           <a:xfrm>
-            <a:off x="914400" y="6016752"/>
-            <a:ext cx="5120640" cy="457200"/>
+            <a:off x="10280142" y="3465576"/>
+            <a:ext cx="1122426" cy="374904"/>
+          </a:xfrm>
+          <a:prstGeom prst="rect">
+            <a:avLst/>
+          </a:prstGeom>
+          <a:noFill/>
+        </p:spPr>
+        <p:txBody>
+          <a:bodyPr wrap="square" anchor="ctr">
+            <a:spAutoFit/>
+          </a:bodyPr>
+          <a:lstStyle/>
+          <a:p>
+            <a:pPr algn="l">
+              <a:spcAft>
+                <a:spcPts val="400"/>
+              </a:spcAft>
+            </a:pPr>
+            <a:r>
+              <a:rPr sz="1100" b="0">
+                <a:solidFill>
+                  <a:srgbClr val="9AA6C8"/>
+                </a:solidFill>
+                <a:latin typeface="Arial"/>
+              </a:rPr>
+              <a:t>$0.10</a:t>
+            </a:r>
+          </a:p>
+        </p:txBody>
+      </p:sp>
+      <p:sp>
+        <p:nvSpPr>
+          <p:cNvPr id="82" name="Rectangle 81"/>
+          <p:cNvSpPr/>
+          <p:nvPr/>
+        </p:nvSpPr>
+        <p:spPr>
+          <a:xfrm>
+            <a:off x="6400800" y="3840480"/>
+            <a:ext cx="2537460" cy="374904"/>
+          </a:xfrm>
+          <a:prstGeom prst="rect">
+            <a:avLst/>
+          </a:prstGeom>
+          <a:solidFill>
+            <a:srgbClr val="151D38"/>
+          </a:solidFill>
+          <a:ln>
+            <a:noFill/>
+          </a:ln>
+          <a:effectLst/>
+        </p:spPr>
+        <p:style>
+          <a:lnRef idx="1">
+            <a:schemeClr val="accent1"/>
+          </a:lnRef>
+          <a:fillRef idx="3">
+            <a:schemeClr val="accent1"/>
+          </a:fillRef>
+          <a:effectRef idx="2">
+            <a:schemeClr val="accent1"/>
+          </a:effectRef>
+          <a:fontRef idx="minor">
+            <a:schemeClr val="lt1"/>
+          </a:fontRef>
+        </p:style>
+        <p:txBody>
+          <a:bodyPr rtlCol="0" anchor="ctr"/>
+          <a:lstStyle/>
+          <a:p>
+            <a:pPr algn="ctr"/>
+          </a:p>
+        </p:txBody>
+      </p:sp>
+      <p:sp>
+        <p:nvSpPr>
+          <p:cNvPr id="83" name="TextBox 82"/>
+          <p:cNvSpPr txBox="1"/>
+          <p:nvPr/>
+        </p:nvSpPr>
+        <p:spPr>
+          <a:xfrm>
+            <a:off x="6473952" y="3840480"/>
+            <a:ext cx="2391156" cy="374904"/>
+          </a:xfrm>
+          <a:prstGeom prst="rect">
+            <a:avLst/>
+          </a:prstGeom>
+          <a:noFill/>
+        </p:spPr>
+        <p:txBody>
+          <a:bodyPr wrap="square" anchor="ctr">
+            <a:spAutoFit/>
+          </a:bodyPr>
+          <a:lstStyle/>
+          <a:p>
+            <a:pPr algn="l">
+              <a:spcAft>
+                <a:spcPts val="400"/>
+              </a:spcAft>
+            </a:pPr>
+            <a:r>
+              <a:rPr sz="1100" b="1">
+                <a:solidFill>
+                  <a:srgbClr val="EDF1FF"/>
+                </a:solidFill>
+                <a:latin typeface="Arial"/>
+              </a:rPr>
+              <a:t>NAT / egress datos</a:t>
+            </a:r>
+          </a:p>
+        </p:txBody>
+      </p:sp>
+      <p:sp>
+        <p:nvSpPr>
+          <p:cNvPr id="84" name="Rectangle 83"/>
+          <p:cNvSpPr/>
+          <p:nvPr/>
+        </p:nvSpPr>
+        <p:spPr>
+          <a:xfrm>
+            <a:off x="8938260" y="3840480"/>
+            <a:ext cx="1268730" cy="374904"/>
+          </a:xfrm>
+          <a:prstGeom prst="rect">
+            <a:avLst/>
+          </a:prstGeom>
+          <a:solidFill>
+            <a:srgbClr val="151D38"/>
+          </a:solidFill>
+          <a:ln>
+            <a:noFill/>
+          </a:ln>
+          <a:effectLst/>
+        </p:spPr>
+        <p:style>
+          <a:lnRef idx="1">
+            <a:schemeClr val="accent1"/>
+          </a:lnRef>
+          <a:fillRef idx="3">
+            <a:schemeClr val="accent1"/>
+          </a:fillRef>
+          <a:effectRef idx="2">
+            <a:schemeClr val="accent1"/>
+          </a:effectRef>
+          <a:fontRef idx="minor">
+            <a:schemeClr val="lt1"/>
+          </a:fontRef>
+        </p:style>
+        <p:txBody>
+          <a:bodyPr rtlCol="0" anchor="ctr"/>
+          <a:lstStyle/>
+          <a:p>
+            <a:pPr algn="ctr"/>
+          </a:p>
+        </p:txBody>
+      </p:sp>
+      <p:sp>
+        <p:nvSpPr>
+          <p:cNvPr id="85" name="TextBox 84"/>
+          <p:cNvSpPr txBox="1"/>
+          <p:nvPr/>
+        </p:nvSpPr>
+        <p:spPr>
+          <a:xfrm>
+            <a:off x="9011412" y="3840480"/>
+            <a:ext cx="1122426" cy="374904"/>
+          </a:xfrm>
+          <a:prstGeom prst="rect">
+            <a:avLst/>
+          </a:prstGeom>
+          <a:noFill/>
+        </p:spPr>
+        <p:txBody>
+          <a:bodyPr wrap="square" anchor="ctr">
+            <a:spAutoFit/>
+          </a:bodyPr>
+          <a:lstStyle/>
+          <a:p>
+            <a:pPr algn="l">
+              <a:spcAft>
+                <a:spcPts val="400"/>
+              </a:spcAft>
+            </a:pPr>
+            <a:r>
+              <a:rPr sz="1100" b="0">
+                <a:solidFill>
+                  <a:srgbClr val="9AA6C8"/>
+                </a:solidFill>
+                <a:latin typeface="Arial"/>
+              </a:rPr>
+              <a:t>$1.0</a:t>
+            </a:r>
+          </a:p>
+        </p:txBody>
+      </p:sp>
+      <p:sp>
+        <p:nvSpPr>
+          <p:cNvPr id="86" name="Rectangle 85"/>
+          <p:cNvSpPr/>
+          <p:nvPr/>
+        </p:nvSpPr>
+        <p:spPr>
+          <a:xfrm>
+            <a:off x="10206990" y="3840480"/>
+            <a:ext cx="1268730" cy="374904"/>
+          </a:xfrm>
+          <a:prstGeom prst="rect">
+            <a:avLst/>
+          </a:prstGeom>
+          <a:solidFill>
+            <a:srgbClr val="151D38"/>
+          </a:solidFill>
+          <a:ln>
+            <a:noFill/>
+          </a:ln>
+          <a:effectLst/>
+        </p:spPr>
+        <p:style>
+          <a:lnRef idx="1">
+            <a:schemeClr val="accent1"/>
+          </a:lnRef>
+          <a:fillRef idx="3">
+            <a:schemeClr val="accent1"/>
+          </a:fillRef>
+          <a:effectRef idx="2">
+            <a:schemeClr val="accent1"/>
+          </a:effectRef>
+          <a:fontRef idx="minor">
+            <a:schemeClr val="lt1"/>
+          </a:fontRef>
+        </p:style>
+        <p:txBody>
+          <a:bodyPr rtlCol="0" anchor="ctr"/>
+          <a:lstStyle/>
+          <a:p>
+            <a:pPr algn="ctr"/>
+          </a:p>
+        </p:txBody>
+      </p:sp>
+      <p:sp>
+        <p:nvSpPr>
+          <p:cNvPr id="87" name="TextBox 86"/>
+          <p:cNvSpPr txBox="1"/>
+          <p:nvPr/>
+        </p:nvSpPr>
+        <p:spPr>
+          <a:xfrm>
+            <a:off x="10280142" y="3840480"/>
+            <a:ext cx="1122426" cy="374904"/>
+          </a:xfrm>
+          <a:prstGeom prst="rect">
+            <a:avLst/>
+          </a:prstGeom>
+          <a:noFill/>
+        </p:spPr>
+        <p:txBody>
+          <a:bodyPr wrap="square" anchor="ctr">
+            <a:spAutoFit/>
+          </a:bodyPr>
+          <a:lstStyle/>
+          <a:p>
+            <a:pPr algn="l">
+              <a:spcAft>
+                <a:spcPts val="400"/>
+              </a:spcAft>
+            </a:pPr>
+            <a:r>
+              <a:rPr sz="1100" b="0">
+                <a:solidFill>
+                  <a:srgbClr val="9AA6C8"/>
+                </a:solidFill>
+                <a:latin typeface="Arial"/>
+              </a:rPr>
+              <a:t>~$0</a:t>
+            </a:r>
+          </a:p>
+        </p:txBody>
+      </p:sp>
+      <p:sp>
+        <p:nvSpPr>
+          <p:cNvPr id="88" name="Rectangle 87"/>
+          <p:cNvSpPr/>
+          <p:nvPr/>
+        </p:nvSpPr>
+        <p:spPr>
+          <a:xfrm>
+            <a:off x="6400800" y="4215384"/>
+            <a:ext cx="2537460" cy="374904"/>
+          </a:xfrm>
+          <a:prstGeom prst="rect">
+            <a:avLst/>
+          </a:prstGeom>
+          <a:solidFill>
+            <a:srgbClr val="10162E"/>
+          </a:solidFill>
+          <a:ln>
+            <a:noFill/>
+          </a:ln>
+          <a:effectLst/>
+        </p:spPr>
+        <p:style>
+          <a:lnRef idx="1">
+            <a:schemeClr val="accent1"/>
+          </a:lnRef>
+          <a:fillRef idx="3">
+            <a:schemeClr val="accent1"/>
+          </a:fillRef>
+          <a:effectRef idx="2">
+            <a:schemeClr val="accent1"/>
+          </a:effectRef>
+          <a:fontRef idx="minor">
+            <a:schemeClr val="lt1"/>
+          </a:fontRef>
+        </p:style>
+        <p:txBody>
+          <a:bodyPr rtlCol="0" anchor="ctr"/>
+          <a:lstStyle/>
+          <a:p>
+            <a:pPr algn="ctr"/>
+          </a:p>
+        </p:txBody>
+      </p:sp>
+      <p:sp>
+        <p:nvSpPr>
+          <p:cNvPr id="89" name="TextBox 88"/>
+          <p:cNvSpPr txBox="1"/>
+          <p:nvPr/>
+        </p:nvSpPr>
+        <p:spPr>
+          <a:xfrm>
+            <a:off x="6473952" y="4215384"/>
+            <a:ext cx="2391156" cy="374904"/>
+          </a:xfrm>
+          <a:prstGeom prst="rect">
+            <a:avLst/>
+          </a:prstGeom>
+          <a:noFill/>
+        </p:spPr>
+        <p:txBody>
+          <a:bodyPr wrap="square" anchor="ctr">
+            <a:spAutoFit/>
+          </a:bodyPr>
+          <a:lstStyle/>
+          <a:p>
+            <a:pPr algn="l">
+              <a:spcAft>
+                <a:spcPts val="400"/>
+              </a:spcAft>
+            </a:pPr>
+            <a:r>
+              <a:rPr sz="1100" b="1">
+                <a:solidFill>
+                  <a:srgbClr val="EDF1FF"/>
+                </a:solidFill>
+                <a:latin typeface="Arial"/>
+              </a:rPr>
+              <a:t>Logs / secrets / misc</a:t>
+            </a:r>
+          </a:p>
+        </p:txBody>
+      </p:sp>
+      <p:sp>
+        <p:nvSpPr>
+          <p:cNvPr id="90" name="Rectangle 89"/>
+          <p:cNvSpPr/>
+          <p:nvPr/>
+        </p:nvSpPr>
+        <p:spPr>
+          <a:xfrm>
+            <a:off x="8938260" y="4215384"/>
+            <a:ext cx="1268730" cy="374904"/>
+          </a:xfrm>
+          <a:prstGeom prst="rect">
+            <a:avLst/>
+          </a:prstGeom>
+          <a:solidFill>
+            <a:srgbClr val="10162E"/>
+          </a:solidFill>
+          <a:ln>
+            <a:noFill/>
+          </a:ln>
+          <a:effectLst/>
+        </p:spPr>
+        <p:style>
+          <a:lnRef idx="1">
+            <a:schemeClr val="accent1"/>
+          </a:lnRef>
+          <a:fillRef idx="3">
+            <a:schemeClr val="accent1"/>
+          </a:fillRef>
+          <a:effectRef idx="2">
+            <a:schemeClr val="accent1"/>
+          </a:effectRef>
+          <a:fontRef idx="minor">
+            <a:schemeClr val="lt1"/>
+          </a:fontRef>
+        </p:style>
+        <p:txBody>
+          <a:bodyPr rtlCol="0" anchor="ctr"/>
+          <a:lstStyle/>
+          <a:p>
+            <a:pPr algn="ctr"/>
+          </a:p>
+        </p:txBody>
+      </p:sp>
+      <p:sp>
+        <p:nvSpPr>
+          <p:cNvPr id="91" name="TextBox 90"/>
+          <p:cNvSpPr txBox="1"/>
+          <p:nvPr/>
+        </p:nvSpPr>
+        <p:spPr>
+          <a:xfrm>
+            <a:off x="9011412" y="4215384"/>
+            <a:ext cx="1122426" cy="374904"/>
+          </a:xfrm>
+          <a:prstGeom prst="rect">
+            <a:avLst/>
+          </a:prstGeom>
+          <a:noFill/>
+        </p:spPr>
+        <p:txBody>
+          <a:bodyPr wrap="square" anchor="ctr">
+            <a:spAutoFit/>
+          </a:bodyPr>
+          <a:lstStyle/>
+          <a:p>
+            <a:pPr algn="l">
+              <a:spcAft>
+                <a:spcPts val="400"/>
+              </a:spcAft>
+            </a:pPr>
+            <a:r>
+              <a:rPr sz="1100" b="0">
+                <a:solidFill>
+                  <a:srgbClr val="9AA6C8"/>
+                </a:solidFill>
+                <a:latin typeface="Arial"/>
+              </a:rPr>
+              <a:t>$0.70</a:t>
+            </a:r>
+          </a:p>
+        </p:txBody>
+      </p:sp>
+      <p:sp>
+        <p:nvSpPr>
+          <p:cNvPr id="92" name="Rectangle 91"/>
+          <p:cNvSpPr/>
+          <p:nvPr/>
+        </p:nvSpPr>
+        <p:spPr>
+          <a:xfrm>
+            <a:off x="10206990" y="4215384"/>
+            <a:ext cx="1268730" cy="374904"/>
+          </a:xfrm>
+          <a:prstGeom prst="rect">
+            <a:avLst/>
+          </a:prstGeom>
+          <a:solidFill>
+            <a:srgbClr val="10162E"/>
+          </a:solidFill>
+          <a:ln>
+            <a:noFill/>
+          </a:ln>
+          <a:effectLst/>
+        </p:spPr>
+        <p:style>
+          <a:lnRef idx="1">
+            <a:schemeClr val="accent1"/>
+          </a:lnRef>
+          <a:fillRef idx="3">
+            <a:schemeClr val="accent1"/>
+          </a:fillRef>
+          <a:effectRef idx="2">
+            <a:schemeClr val="accent1"/>
+          </a:effectRef>
+          <a:fontRef idx="minor">
+            <a:schemeClr val="lt1"/>
+          </a:fontRef>
+        </p:style>
+        <p:txBody>
+          <a:bodyPr rtlCol="0" anchor="ctr"/>
+          <a:lstStyle/>
+          <a:p>
+            <a:pPr algn="ctr"/>
+          </a:p>
+        </p:txBody>
+      </p:sp>
+      <p:sp>
+        <p:nvSpPr>
+          <p:cNvPr id="93" name="TextBox 92"/>
+          <p:cNvSpPr txBox="1"/>
+          <p:nvPr/>
+        </p:nvSpPr>
+        <p:spPr>
+          <a:xfrm>
+            <a:off x="10280142" y="4215384"/>
+            <a:ext cx="1122426" cy="374904"/>
+          </a:xfrm>
+          <a:prstGeom prst="rect">
+            <a:avLst/>
+          </a:prstGeom>
+          <a:noFill/>
+        </p:spPr>
+        <p:txBody>
+          <a:bodyPr wrap="square" anchor="ctr">
+            <a:spAutoFit/>
+          </a:bodyPr>
+          <a:lstStyle/>
+          <a:p>
+            <a:pPr algn="l">
+              <a:spcAft>
+                <a:spcPts val="400"/>
+              </a:spcAft>
+            </a:pPr>
+            <a:r>
+              <a:rPr sz="1100" b="0">
+                <a:solidFill>
+                  <a:srgbClr val="9AA6C8"/>
+                </a:solidFill>
+                <a:latin typeface="Arial"/>
+              </a:rPr>
+              <a:t>~$0</a:t>
+            </a:r>
+          </a:p>
+        </p:txBody>
+      </p:sp>
+      <p:sp>
+        <p:nvSpPr>
+          <p:cNvPr id="94" name="Rectangle 93"/>
+          <p:cNvSpPr/>
+          <p:nvPr/>
+        </p:nvSpPr>
+        <p:spPr>
+          <a:xfrm>
+            <a:off x="6400800" y="4590288"/>
+            <a:ext cx="2537460" cy="374904"/>
+          </a:xfrm>
+          <a:prstGeom prst="rect">
+            <a:avLst/>
+          </a:prstGeom>
+          <a:solidFill>
+            <a:srgbClr val="151D38"/>
+          </a:solidFill>
+          <a:ln>
+            <a:noFill/>
+          </a:ln>
+          <a:effectLst/>
+        </p:spPr>
+        <p:style>
+          <a:lnRef idx="1">
+            <a:schemeClr val="accent1"/>
+          </a:lnRef>
+          <a:fillRef idx="3">
+            <a:schemeClr val="accent1"/>
+          </a:fillRef>
+          <a:effectRef idx="2">
+            <a:schemeClr val="accent1"/>
+          </a:effectRef>
+          <a:fontRef idx="minor">
+            <a:schemeClr val="lt1"/>
+          </a:fontRef>
+        </p:style>
+        <p:txBody>
+          <a:bodyPr rtlCol="0" anchor="ctr"/>
+          <a:lstStyle/>
+          <a:p>
+            <a:pPr algn="ctr"/>
+          </a:p>
+        </p:txBody>
+      </p:sp>
+      <p:sp>
+        <p:nvSpPr>
+          <p:cNvPr id="95" name="TextBox 94"/>
+          <p:cNvSpPr txBox="1"/>
+          <p:nvPr/>
+        </p:nvSpPr>
+        <p:spPr>
+          <a:xfrm>
+            <a:off x="6473952" y="4590288"/>
+            <a:ext cx="2391156" cy="374904"/>
+          </a:xfrm>
+          <a:prstGeom prst="rect">
+            <a:avLst/>
+          </a:prstGeom>
+          <a:noFill/>
+        </p:spPr>
+        <p:txBody>
+          <a:bodyPr wrap="square" anchor="ctr">
+            <a:spAutoFit/>
+          </a:bodyPr>
+          <a:lstStyle/>
+          <a:p>
+            <a:pPr algn="l">
+              <a:spcAft>
+                <a:spcPts val="400"/>
+              </a:spcAft>
+            </a:pPr>
+            <a:r>
+              <a:rPr sz="1100" b="1">
+                <a:solidFill>
+                  <a:srgbClr val="EDF1FF"/>
+                </a:solidFill>
+                <a:latin typeface="Arial"/>
+              </a:rPr>
+              <a:t>POR EQUIPO</a:t>
+            </a:r>
+          </a:p>
+        </p:txBody>
+      </p:sp>
+      <p:sp>
+        <p:nvSpPr>
+          <p:cNvPr id="96" name="Rectangle 95"/>
+          <p:cNvSpPr/>
+          <p:nvPr/>
+        </p:nvSpPr>
+        <p:spPr>
+          <a:xfrm>
+            <a:off x="8938260" y="4590288"/>
+            <a:ext cx="1268730" cy="374904"/>
+          </a:xfrm>
+          <a:prstGeom prst="rect">
+            <a:avLst/>
+          </a:prstGeom>
+          <a:solidFill>
+            <a:srgbClr val="151D38"/>
+          </a:solidFill>
+          <a:ln>
+            <a:noFill/>
+          </a:ln>
+          <a:effectLst/>
+        </p:spPr>
+        <p:style>
+          <a:lnRef idx="1">
+            <a:schemeClr val="accent1"/>
+          </a:lnRef>
+          <a:fillRef idx="3">
+            <a:schemeClr val="accent1"/>
+          </a:fillRef>
+          <a:effectRef idx="2">
+            <a:schemeClr val="accent1"/>
+          </a:effectRef>
+          <a:fontRef idx="minor">
+            <a:schemeClr val="lt1"/>
+          </a:fontRef>
+        </p:style>
+        <p:txBody>
+          <a:bodyPr rtlCol="0" anchor="ctr"/>
+          <a:lstStyle/>
+          <a:p>
+            <a:pPr algn="ctr"/>
+          </a:p>
+        </p:txBody>
+      </p:sp>
+      <p:sp>
+        <p:nvSpPr>
+          <p:cNvPr id="97" name="TextBox 96"/>
+          <p:cNvSpPr txBox="1"/>
+          <p:nvPr/>
+        </p:nvSpPr>
+        <p:spPr>
+          <a:xfrm>
+            <a:off x="9011412" y="4590288"/>
+            <a:ext cx="1122426" cy="374904"/>
+          </a:xfrm>
+          <a:prstGeom prst="rect">
+            <a:avLst/>
+          </a:prstGeom>
+          <a:noFill/>
+        </p:spPr>
+        <p:txBody>
+          <a:bodyPr wrap="square" anchor="ctr">
+            <a:spAutoFit/>
+          </a:bodyPr>
+          <a:lstStyle/>
+          <a:p>
+            <a:pPr algn="l">
+              <a:spcAft>
+                <a:spcPts val="400"/>
+              </a:spcAft>
+            </a:pPr>
+            <a:r>
+              <a:rPr sz="1100" b="0">
+                <a:solidFill>
+                  <a:srgbClr val="9AA6C8"/>
+                </a:solidFill>
+                <a:latin typeface="Arial"/>
+              </a:rPr>
+              <a:t>≈ $5–8</a:t>
+            </a:r>
+          </a:p>
+        </p:txBody>
+      </p:sp>
+      <p:sp>
+        <p:nvSpPr>
+          <p:cNvPr id="98" name="Rectangle 97"/>
+          <p:cNvSpPr/>
+          <p:nvPr/>
+        </p:nvSpPr>
+        <p:spPr>
+          <a:xfrm>
+            <a:off x="10206990" y="4590288"/>
+            <a:ext cx="1268730" cy="374904"/>
+          </a:xfrm>
+          <a:prstGeom prst="rect">
+            <a:avLst/>
+          </a:prstGeom>
+          <a:solidFill>
+            <a:srgbClr val="151D38"/>
+          </a:solidFill>
+          <a:ln>
+            <a:noFill/>
+          </a:ln>
+          <a:effectLst/>
+        </p:spPr>
+        <p:style>
+          <a:lnRef idx="1">
+            <a:schemeClr val="accent1"/>
+          </a:lnRef>
+          <a:fillRef idx="3">
+            <a:schemeClr val="accent1"/>
+          </a:fillRef>
+          <a:effectRef idx="2">
+            <a:schemeClr val="accent1"/>
+          </a:effectRef>
+          <a:fontRef idx="minor">
+            <a:schemeClr val="lt1"/>
+          </a:fontRef>
+        </p:style>
+        <p:txBody>
+          <a:bodyPr rtlCol="0" anchor="ctr"/>
+          <a:lstStyle/>
+          <a:p>
+            <a:pPr algn="ctr"/>
+          </a:p>
+        </p:txBody>
+      </p:sp>
+      <p:sp>
+        <p:nvSpPr>
+          <p:cNvPr id="99" name="TextBox 98"/>
+          <p:cNvSpPr txBox="1"/>
+          <p:nvPr/>
+        </p:nvSpPr>
+        <p:spPr>
+          <a:xfrm>
+            <a:off x="10280142" y="4590288"/>
+            <a:ext cx="1122426" cy="374904"/>
+          </a:xfrm>
+          <a:prstGeom prst="rect">
+            <a:avLst/>
+          </a:prstGeom>
+          <a:noFill/>
+        </p:spPr>
+        <p:txBody>
+          <a:bodyPr wrap="square" anchor="ctr">
+            <a:spAutoFit/>
+          </a:bodyPr>
+          <a:lstStyle/>
+          <a:p>
+            <a:pPr algn="l">
+              <a:spcAft>
+                <a:spcPts val="400"/>
+              </a:spcAft>
+            </a:pPr>
+            <a:r>
+              <a:rPr sz="1100" b="0">
+                <a:solidFill>
+                  <a:srgbClr val="9AA6C8"/>
+                </a:solidFill>
+                <a:latin typeface="Arial"/>
+              </a:rPr>
+              <a:t>≈ $0–2</a:t>
+            </a:r>
+          </a:p>
+        </p:txBody>
+      </p:sp>
+      <p:sp>
+        <p:nvSpPr>
+          <p:cNvPr id="100" name="Rectangle 99"/>
+          <p:cNvSpPr/>
+          <p:nvPr/>
+        </p:nvSpPr>
+        <p:spPr>
+          <a:xfrm>
+            <a:off x="6400800" y="5440680"/>
+            <a:ext cx="5074920" cy="1051560"/>
+          </a:xfrm>
+          <a:prstGeom prst="rect">
+            <a:avLst/>
+          </a:prstGeom>
+          <a:solidFill>
+            <a:srgbClr val="151D38"/>
+          </a:solidFill>
+          <a:ln>
+            <a:noFill/>
+          </a:ln>
+          <a:effectLst/>
+        </p:spPr>
+        <p:style>
+          <a:lnRef idx="1">
+            <a:schemeClr val="accent1"/>
+          </a:lnRef>
+          <a:fillRef idx="3">
+            <a:schemeClr val="accent1"/>
+          </a:fillRef>
+          <a:effectRef idx="2">
+            <a:schemeClr val="accent1"/>
+          </a:effectRef>
+          <a:fontRef idx="minor">
+            <a:schemeClr val="lt1"/>
+          </a:fontRef>
+        </p:style>
+        <p:txBody>
+          <a:bodyPr rtlCol="0" anchor="ctr"/>
+          <a:lstStyle/>
+          <a:p>
+            <a:pPr algn="ctr"/>
+          </a:p>
+        </p:txBody>
+      </p:sp>
+      <p:sp>
+        <p:nvSpPr>
+          <p:cNvPr id="101" name="TextBox 100"/>
+          <p:cNvSpPr txBox="1"/>
+          <p:nvPr/>
+        </p:nvSpPr>
+        <p:spPr>
+          <a:xfrm>
+            <a:off x="6583680" y="5532120"/>
+            <a:ext cx="4754880" cy="914400"/>
           </a:xfrm>
           <a:prstGeom prst="rect">
             <a:avLst/>
@@ -20554,22 +22039,114 @@
               </a:spcAft>
             </a:pPr>
             <a:r>
-              <a:rPr sz="1150" b="1">
-                <a:solidFill>
-                  <a:srgbClr val="F26D6D"/>
-                </a:solidFill>
-                <a:latin typeface="Arial"/>
-              </a:rPr>
-              <a:t>Filestore (caro) solo opt-in.  </a:t>
-            </a:r>
-            <a:r>
-              <a:rPr sz="1150" b="0">
+              <a:rPr sz="1200" b="1">
+                <a:solidFill>
+                  <a:srgbClr val="F5A623"/>
+                </a:solidFill>
+                <a:latin typeface="Arial"/>
+              </a:rPr>
+              <a:t>API LLM:  </a:t>
+            </a:r>
+            <a:r>
+              <a:rPr sz="1200" b="0">
                 <a:solidFill>
                   <a:srgbClr val="9AA6C8"/>
                 </a:solidFill>
                 <a:latin typeface="Arial"/>
               </a:rPr>
-              <a:t>Default = GCS+gcsfuse.</a:t>
+              <a:t>Free = BYO (costo $0 para nosotros).  Pro = pass-through + markup → ingreso positivo, no costo neto.</a:t>
+            </a:r>
+          </a:p>
+        </p:txBody>
+      </p:sp>
+      <p:sp>
+        <p:nvSpPr>
+          <p:cNvPr id="102" name="Rectangle 101"/>
+          <p:cNvSpPr/>
+          <p:nvPr/>
+        </p:nvSpPr>
+        <p:spPr>
+          <a:xfrm>
+            <a:off x="731520" y="5897880"/>
+            <a:ext cx="5394960" cy="594360"/>
+          </a:xfrm>
+          <a:prstGeom prst="rect">
+            <a:avLst/>
+          </a:prstGeom>
+          <a:solidFill>
+            <a:srgbClr val="151D38"/>
+          </a:solidFill>
+          <a:ln>
+            <a:noFill/>
+          </a:ln>
+          <a:effectLst/>
+        </p:spPr>
+        <p:style>
+          <a:lnRef idx="1">
+            <a:schemeClr val="accent1"/>
+          </a:lnRef>
+          <a:fillRef idx="3">
+            <a:schemeClr val="accent1"/>
+          </a:fillRef>
+          <a:effectRef idx="2">
+            <a:schemeClr val="accent1"/>
+          </a:effectRef>
+          <a:fontRef idx="minor">
+            <a:schemeClr val="lt1"/>
+          </a:fontRef>
+        </p:style>
+        <p:txBody>
+          <a:bodyPr rtlCol="0" anchor="ctr"/>
+          <a:lstStyle/>
+          <a:p>
+            <a:pPr algn="ctr"/>
+          </a:p>
+        </p:txBody>
+      </p:sp>
+      <p:sp>
+        <p:nvSpPr>
+          <p:cNvPr id="103" name="TextBox 102"/>
+          <p:cNvSpPr txBox="1"/>
+          <p:nvPr/>
+        </p:nvSpPr>
+        <p:spPr>
+          <a:xfrm>
+            <a:off x="914400" y="5961888"/>
+            <a:ext cx="5120640" cy="502920"/>
+          </a:xfrm>
+          <a:prstGeom prst="rect">
+            <a:avLst/>
+          </a:prstGeom>
+          <a:noFill/>
+        </p:spPr>
+        <p:txBody>
+          <a:bodyPr wrap="square" anchor="t">
+            <a:spAutoFit/>
+          </a:bodyPr>
+          <a:lstStyle/>
+          <a:p>
+            <a:pPr algn="l">
+              <a:spcAft>
+                <a:spcPts val="400"/>
+              </a:spcAft>
+            </a:pPr>
+            <a:r>
+              <a:rPr sz="1050" b="1">
+                <a:solidFill>
+                  <a:srgbClr val="F5A623"/>
+                </a:solidFill>
+                <a:latin typeface="Arial"/>
+              </a:rPr>
+              <a:t>* </a:t>
+            </a:r>
+            <a:r>
+              <a:rPr sz="1050" b="0">
+                <a:solidFill>
+                  <a:srgbClr val="9AA6C8"/>
+                </a:solidFill>
+                <a:latin typeface="Arial"/>
+              </a:rPr>
+              <a:t>Uso ligero de prueba cae en la cuota always-free de Cloud Run = $0 cómputo. Filestore (caro) solo opt-in en Pago.</a:t>
             </a:r>
           </a:p>
         </p:txBody>

</xml_diff>